<commit_message>
(feat) modificado la presentacion con informacion actualizada del proyecto
</commit_message>
<xml_diff>
--- a/presentacion/Resumen_Presentacion.pptx
+++ b/presentacion/Resumen_Presentacion.pptx
@@ -305,7 +305,7 @@
       <c:catAx>
         <c:axId val="2094734554"/>
         <c:scaling>
-          <c:orientation val="minMax"/>
+          <c:orientation val="maxMin"/>
         </c:scaling>
         <c:delete val="0"/>
         <c:axPos val="l"/>
@@ -2633,7 +2633,7 @@
                 </a:solidFill>
                 <a:latin typeface="Calibri"/>
               </a:rPr>
-              <a:t>ROA de cartera — actual vs. propuesto</a:t>
+              <a:t>ROA real por banda de riesgo</a:t>
             </a:r>
           </a:p>
         </c:rich>
@@ -2656,20 +2656,64 @@
               <c:strCache>
                 <c:ptCount val="1"/>
                 <c:pt idx="0">
-                  <c:v>Política actual</c:v>
+                  <c:v>ROA (%)</c:v>
                 </c:pt>
               </c:strCache>
             </c:strRef>
           </c:tx>
           <c:spPr>
             <a:solidFill>
-              <a:srgbClr val="5B6584"/>
+              <a:srgbClr val="1E2761"/>
             </a:solidFill>
             <a:effectLst/>
           </c:spPr>
           <c:invertIfNegative val="0"/>
+          <c:dPt>
+            <c:idx val="0"/>
+            <c:invertIfNegative val="0"/>
+            <c:bubble3D val="0"/>
+            <c:spPr>
+              <a:solidFill>
+                <a:srgbClr val="2E8B57"/>
+              </a:solidFill>
+              <a:effectLst/>
+            </c:spPr>
+          </c:dPt>
+          <c:dPt>
+            <c:idx val="1"/>
+            <c:invertIfNegative val="0"/>
+            <c:bubble3D val="0"/>
+            <c:spPr>
+              <a:solidFill>
+                <a:srgbClr val="C9A227"/>
+              </a:solidFill>
+              <a:effectLst/>
+            </c:spPr>
+          </c:dPt>
+          <c:dPt>
+            <c:idx val="2"/>
+            <c:invertIfNegative val="0"/>
+            <c:bubble3D val="0"/>
+            <c:spPr>
+              <a:solidFill>
+                <a:srgbClr val="D97C3D"/>
+              </a:solidFill>
+              <a:effectLst/>
+            </c:spPr>
+          </c:dPt>
+          <c:dPt>
+            <c:idx val="3"/>
+            <c:invertIfNegative val="0"/>
+            <c:bubble3D val="0"/>
+            <c:spPr>
+              <a:solidFill>
+                <a:srgbClr val="B84C4C"/>
+              </a:solidFill>
+              <a:effectLst/>
+            </c:spPr>
+          </c:dPt>
           <c:dLbls>
-            <c:numFmt formatCode="0.00" sourceLinked="0"/>
+            <c:numFmt formatCode="0.0" sourceLinked="0"/>
             <c:spPr>
               <a:noFill/>
               <a:ln>
@@ -2707,117 +2751,48 @@
           </c:dLbls>
           <c:cat>
             <c:strRef>
-              <c:f>Sheet1!$A$2:$A$2</c:f>
+              <c:f>Sheet1!$A$2:$A$5</c:f>
               <c:strCache>
-                <c:ptCount val="1"/>
+                <c:ptCount val="4"/>
                 <c:pt idx="0">
-                  <c:v>ROA cartera (%)</c:v>
+                  <c:v>Bajo Riesgo</c:v>
+                </c:pt>
+                <c:pt idx="1">
+                  <c:v>Medio Riesgo</c:v>
+                </c:pt>
+                <c:pt idx="2">
+                  <c:v>Alto Riesgo</c:v>
+                </c:pt>
+                <c:pt idx="3">
+                  <c:v>Muy Alto Riesgo</c:v>
                 </c:pt>
               </c:strCache>
             </c:strRef>
           </c:cat>
           <c:val>
             <c:numRef>
-              <c:f>Sheet1!$B$2:$B$2</c:f>
+              <c:f>Sheet1!$B$2:$B$5</c:f>
               <c:numCache>
-                <c:formatCode>General</c:formatCode>
-                <c:ptCount val="1"/>
+                <c:formatCode>0.0</c:formatCode>
+                <c:ptCount val="4"/>
                 <c:pt idx="0">
-                  <c:v>1.85</c:v>
+                  <c:v>4.7</c:v>
+                </c:pt>
+                <c:pt idx="1">
+                  <c:v>7.4</c:v>
+                </c:pt>
+                <c:pt idx="2">
+                  <c:v>12.9</c:v>
+                </c:pt>
+                <c:pt idx="3">
+                  <c:v>-3.9</c:v>
                 </c:pt>
               </c:numCache>
             </c:numRef>
           </c:val>
           <c:extLst>
             <c:ext xmlns:c16="http://schemas.microsoft.com/office/drawing/2014/chart" uri="{C3380CC4-5D6E-409C-BE32-E72D297353CC}">
-              <c16:uniqueId val="{00000000-BB37-A447-90E3-585773E07476}"/>
-            </c:ext>
-          </c:extLst>
-        </c:ser>
-        <c:ser>
-          <c:idx val="1"/>
-          <c:order val="1"/>
-          <c:tx>
-            <c:strRef>
-              <c:f>Sheet1!$C$1</c:f>
-              <c:strCache>
-                <c:ptCount val="1"/>
-                <c:pt idx="0">
-                  <c:v>Modelo propuesto</c:v>
-                </c:pt>
-              </c:strCache>
-            </c:strRef>
-          </c:tx>
-          <c:spPr>
-            <a:solidFill>
-              <a:srgbClr val="2E8B57"/>
-            </a:solidFill>
-            <a:effectLst/>
-          </c:spPr>
-          <c:invertIfNegative val="0"/>
-          <c:dLbls>
-            <c:numFmt formatCode="0.00" sourceLinked="0"/>
-            <c:spPr>
-              <a:noFill/>
-              <a:ln>
-                <a:noFill/>
-              </a:ln>
-              <a:effectLst/>
-            </c:spPr>
-            <c:txPr>
-              <a:bodyPr/>
-              <a:lstStyle/>
-              <a:p>
-                <a:pPr>
-                  <a:defRPr sz="1100" b="0" i="0" u="none" strike="noStrike">
-                    <a:solidFill>
-                      <a:srgbClr val="141A45"/>
-                    </a:solidFill>
-                    <a:latin typeface="Arial"/>
-                  </a:defRPr>
-                </a:pPr>
-                <a:endParaRPr lang="en-PE"/>
-              </a:p>
-            </c:txPr>
-            <c:showLegendKey val="0"/>
-            <c:showVal val="1"/>
-            <c:showCatName val="0"/>
-            <c:showSerName val="0"/>
-            <c:showPercent val="0"/>
-            <c:showBubbleSize val="0"/>
-            <c:showLeaderLines val="0"/>
-            <c:extLst>
-              <c:ext xmlns:c15="http://schemas.microsoft.com/office/drawing/2012/chart" uri="{CE6537A1-D6FC-4f65-9D91-7224C49458BB}">
-                <c15:showLeaderLines val="0"/>
-              </c:ext>
-            </c:extLst>
-          </c:dLbls>
-          <c:cat>
-            <c:strRef>
-              <c:f>Sheet1!$A$2:$A$2</c:f>
-              <c:strCache>
-                <c:ptCount val="1"/>
-                <c:pt idx="0">
-                  <c:v>ROA cartera (%)</c:v>
-                </c:pt>
-              </c:strCache>
-            </c:strRef>
-          </c:cat>
-          <c:val>
-            <c:numRef>
-              <c:f>Sheet1!$C$2:$C$2</c:f>
-              <c:numCache>
-                <c:formatCode>General</c:formatCode>
-                <c:ptCount val="1"/>
-                <c:pt idx="0">
-                  <c:v>2.2000000000000002</c:v>
-                </c:pt>
-              </c:numCache>
-            </c:numRef>
-          </c:val>
-          <c:extLst>
-            <c:ext xmlns:c16="http://schemas.microsoft.com/office/drawing/2014/chart" uri="{C3380CC4-5D6E-409C-BE32-E72D297353CC}">
-              <c16:uniqueId val="{00000001-BB37-A447-90E3-585773E07476}"/>
+              <c16:uniqueId val="{00000000-BB37-A447-90E3-585773E07477}"/>
             </c:ext>
           </c:extLst>
         </c:ser>
@@ -2829,7 +2804,7 @@
           <c:showPercent val="0"/>
           <c:showBubbleSize val="0"/>
         </c:dLbls>
-        <c:gapWidth val="60"/>
+        <c:gapWidth val="40"/>
         <c:axId val="2094734554"/>
         <c:axId val="2094734552"/>
       </c:barChart>
@@ -2858,7 +2833,7 @@
           <a:lstStyle/>
           <a:p>
             <a:pPr>
-              <a:defRPr sz="1050" b="0" i="0" u="none" strike="noStrike">
+              <a:defRPr sz="1000" b="0" i="0" u="none" strike="noStrike">
                 <a:solidFill>
                   <a:srgbClr val="000000"/>
                 </a:solidFill>
@@ -2900,20 +2875,6 @@
         <a:effectLst/>
       </c:spPr>
     </c:plotArea>
-    <c:legend>
-      <c:legendPos val="b"/>
-      <c:overlay val="0"/>
-      <c:txPr>
-        <a:bodyPr/>
-        <a:lstStyle/>
-        <a:p>
-          <a:pPr>
-            <a:defRPr sz="1000"/>
-          </a:pPr>
-          <a:endParaRPr lang="en-US"/>
-        </a:p>
-      </c:txPr>
-    </c:legend>
     <c:plotVisOnly val="1"/>
     <c:dispBlanksAs val="span"/>
     <c:showDLblsOverMax val="1"/>
@@ -8307,14 +8268,131 @@
       </p:sp>
       <p:sp>
         <p:nvSpPr>
-          <p:cNvPr id="4" name="Shape 2"/>
+          <p:cNvPr id="28" name="Text 26"/>
+          <p:cNvSpPr/>
+          <p:nvPr/>
+        </p:nvSpPr>
+        <p:spPr>
+          <a:xfrm>
+            <a:off x="548640" y="5486400"/>
+            <a:ext cx="11064240" cy="457200"/>
+          </a:xfrm>
+          <a:prstGeom prst="rect">
+            <a:avLst/>
+          </a:prstGeom>
+          <a:noFill/>
+          <a:ln/>
+        </p:spPr>
+        <p:txBody>
+          <a:bodyPr wrap="square" lIns="0" tIns="0" rIns="0" bIns="0" rtlCol="0" anchor="ctr"/>
+          <a:lstStyle/>
+          <a:p>
+            <a:pPr marL="0" indent="0">
+              <a:buNone/>
+            </a:pPr>
+            <a:r>
+              <a:rPr lang="en-US" sz="1200" i="1" dirty="0">
+                <a:solidFill>
+                  <a:srgbClr val="5B6584"/>
+                </a:solidFill>
+                <a:latin typeface="Calibri" pitchFamily="34" charset="0"/>
+                <a:ea typeface="Calibri" pitchFamily="34" charset="-122"/>
+                <a:cs typeface="Calibri" pitchFamily="34" charset="-120"/>
+              </a:rPr>
+              <a:t>Las 4 bandas son fijas (no un cutoff continuo) y ya están calibradas en producción — ver la economía real de cada banda en la sección de impacto económico.</a:t>
+            </a:r>
+            <a:endParaRPr lang="en-US" sz="1200" dirty="0"/>
+          </a:p>
+        </p:txBody>
+      </p:sp>
+      <p:sp>
+        <p:nvSpPr>
+          <p:cNvPr id="29" name="Text 27"/>
+          <p:cNvSpPr/>
+          <p:nvPr/>
+        </p:nvSpPr>
+        <p:spPr>
+          <a:xfrm>
+            <a:off x="457200" y="6537960"/>
+            <a:ext cx="7315200" cy="274320"/>
+          </a:xfrm>
+          <a:prstGeom prst="rect">
+            <a:avLst/>
+          </a:prstGeom>
+          <a:noFill/>
+          <a:ln/>
+        </p:spPr>
+        <p:txBody>
+          <a:bodyPr wrap="square" lIns="0" tIns="0" rIns="0" bIns="0" rtlCol="0" anchor="ctr"/>
+          <a:lstStyle/>
+          <a:p>
+            <a:pPr marL="0" indent="0">
+              <a:buNone/>
+            </a:pPr>
+            <a:r>
+              <a:rPr lang="en-US" sz="900" i="1" dirty="0">
+                <a:solidFill>
+                  <a:srgbClr val="5B6584"/>
+                </a:solidFill>
+                <a:latin typeface="Calibri" pitchFamily="34" charset="0"/>
+                <a:ea typeface="Calibri" pitchFamily="34" charset="-122"/>
+                <a:cs typeface="Calibri" pitchFamily="34" charset="-120"/>
+              </a:rPr>
+              <a:t>Give Me Credit — Modelo de Scoring de Riesgo Crediticio</a:t>
+            </a:r>
+            <a:endParaRPr lang="en-US" sz="900" dirty="0"/>
+          </a:p>
+        </p:txBody>
+      </p:sp>
+      <p:sp>
+        <p:nvSpPr>
+          <p:cNvPr id="30" name="Text 28"/>
+          <p:cNvSpPr/>
+          <p:nvPr/>
+        </p:nvSpPr>
+        <p:spPr>
+          <a:xfrm>
+            <a:off x="11521440" y="6537960"/>
+            <a:ext cx="365760" cy="274320"/>
+          </a:xfrm>
+          <a:prstGeom prst="rect">
+            <a:avLst/>
+          </a:prstGeom>
+          <a:noFill/>
+          <a:ln/>
+        </p:spPr>
+        <p:txBody>
+          <a:bodyPr wrap="square" lIns="0" tIns="0" rIns="0" bIns="0" rtlCol="0" anchor="ctr"/>
+          <a:lstStyle/>
+          <a:p>
+            <a:pPr marL="0" indent="0" algn="r">
+              <a:buNone/>
+            </a:pPr>
+            <a:r>
+              <a:rPr lang="en-US" sz="900" dirty="0">
+                <a:solidFill>
+                  <a:srgbClr val="5B6584"/>
+                </a:solidFill>
+                <a:latin typeface="Calibri" pitchFamily="34" charset="0"/>
+                <a:ea typeface="Calibri" pitchFamily="34" charset="-122"/>
+                <a:cs typeface="Calibri" pitchFamily="34" charset="-120"/>
+              </a:rPr>
+              <a:t>14</a:t>
+            </a:r>
+            <a:endParaRPr lang="en-US" sz="900" dirty="0"/>
+          </a:p>
+        </p:txBody>
+      </p:sp>
+      <p:sp>
+        <p:nvSpPr>
+          <p:cNvPr id="400" name="Banda0Shape4"/>
           <p:cNvSpPr/>
           <p:nvPr/>
         </p:nvSpPr>
         <p:spPr>
           <a:xfrm>
             <a:off x="548640" y="1737360"/>
-            <a:ext cx="3566160" cy="3566160"/>
+            <a:ext cx="2594610" cy="3566160"/>
           </a:xfrm>
           <a:prstGeom prst="roundRect">
             <a:avLst>
@@ -8348,7 +8426,7 @@
       </p:sp>
       <p:sp>
         <p:nvSpPr>
-          <p:cNvPr id="5" name="Shape 3"/>
+          <p:cNvPr id="401" name="Banda0Shape5"/>
           <p:cNvSpPr/>
           <p:nvPr/>
         </p:nvSpPr>
@@ -8375,7 +8453,7 @@
       </p:sp>
       <p:sp>
         <p:nvSpPr>
-          <p:cNvPr id="6" name="Text 4"/>
+          <p:cNvPr id="402" name="Banda0Shape6"/>
           <p:cNvSpPr/>
           <p:nvPr/>
         </p:nvSpPr>
@@ -8398,7 +8476,7 @@
               <a:buNone/>
             </a:pPr>
             <a:r>
-              <a:rPr lang="en-US" sz="1400" b="1" dirty="0">
+              <a:rPr lang="en-US" sz="1150" b="1" dirty="0">
                 <a:solidFill>
                   <a:srgbClr val="FFFFFF"/>
                 </a:solidFill>
@@ -8408,20 +8486,20 @@
               </a:rPr>
               <a:t>●</a:t>
             </a:r>
-            <a:endParaRPr lang="en-US" sz="1400" dirty="0"/>
-          </a:p>
-        </p:txBody>
-      </p:sp>
-      <p:sp>
-        <p:nvSpPr>
-          <p:cNvPr id="7" name="Text 5"/>
+            <a:endParaRPr lang="en-US" sz="1150" dirty="0"/>
+          </a:p>
+        </p:txBody>
+      </p:sp>
+      <p:sp>
+        <p:nvSpPr>
+          <p:cNvPr id="403" name="Banda0Shape7"/>
           <p:cNvSpPr/>
           <p:nvPr/>
         </p:nvSpPr>
         <p:spPr>
           <a:xfrm>
             <a:off x="1463040" y="2029968"/>
-            <a:ext cx="2377440" cy="365760"/>
+            <a:ext cx="1405890" cy="502920"/>
           </a:xfrm>
           <a:prstGeom prst="rect">
             <a:avLst/>
@@ -8437,7 +8515,7 @@
               <a:buNone/>
             </a:pPr>
             <a:r>
-              <a:rPr lang="en-US" sz="1700" b="1" dirty="0">
+              <a:rPr lang="en-US" sz="1150" b="1" dirty="0">
                 <a:solidFill>
                   <a:srgbClr val="1E2761"/>
                 </a:solidFill>
@@ -8445,7 +8523,7 @@
                 <a:ea typeface="Cambria" pitchFamily="34" charset="-122"/>
                 <a:cs typeface="Cambria" pitchFamily="34" charset="-120"/>
               </a:rPr>
-              <a:t>Riesgo Bajo</a:t>
+              <a:t>Bajo Riesgo</a:t>
             </a:r>
             <a:endParaRPr lang="en-US" sz="1700" dirty="0"/>
           </a:p>
@@ -8453,14 +8531,14 @@
       </p:sp>
       <p:sp>
         <p:nvSpPr>
-          <p:cNvPr id="8" name="Text 6"/>
+          <p:cNvPr id="404" name="Banda0Shape8"/>
           <p:cNvSpPr/>
           <p:nvPr/>
         </p:nvSpPr>
         <p:spPr>
           <a:xfrm>
             <a:off x="822960" y="2606040"/>
-            <a:ext cx="3017520" cy="320040"/>
+            <a:ext cx="2045970" cy="320040"/>
           </a:xfrm>
           <a:prstGeom prst="rect">
             <a:avLst/>
@@ -8476,7 +8554,7 @@
               <a:buNone/>
             </a:pPr>
             <a:r>
-              <a:rPr lang="en-US" sz="1300" dirty="0">
+              <a:rPr lang="en-US" sz="1050" dirty="0">
                 <a:solidFill>
                   <a:srgbClr val="5B6584"/>
                 </a:solidFill>
@@ -8484,7 +8562,7 @@
                 <a:ea typeface="Calibri" pitchFamily="34" charset="-122"/>
                 <a:cs typeface="Calibri" pitchFamily="34" charset="-120"/>
               </a:rPr>
-              <a:t>Score ≥ 700</a:t>
+              <a:t>Umbral de PD</a:t>
             </a:r>
             <a:endParaRPr lang="en-US" sz="1300" dirty="0"/>
           </a:p>
@@ -8492,14 +8570,14 @@
       </p:sp>
       <p:sp>
         <p:nvSpPr>
-          <p:cNvPr id="9" name="Text 7"/>
+          <p:cNvPr id="405" name="Banda0Shape9"/>
           <p:cNvSpPr/>
           <p:nvPr/>
         </p:nvSpPr>
         <p:spPr>
           <a:xfrm>
             <a:off x="822960" y="2971800"/>
-            <a:ext cx="3017520" cy="502920"/>
+            <a:ext cx="2045970" cy="502920"/>
           </a:xfrm>
           <a:prstGeom prst="rect">
             <a:avLst/>
@@ -8515,7 +8593,7 @@
               <a:buNone/>
             </a:pPr>
             <a:r>
-              <a:rPr lang="en-US" sz="2200" b="1" dirty="0">
+              <a:rPr lang="en-US" sz="1800" b="1" dirty="0">
                 <a:solidFill>
                   <a:srgbClr val="2E8B57"/>
                 </a:solidFill>
@@ -8523,7 +8601,7 @@
                 <a:ea typeface="Cambria" pitchFamily="34" charset="-122"/>
                 <a:cs typeface="Cambria" pitchFamily="34" charset="-120"/>
               </a:rPr>
-              <a:t>PD &lt; 2%</a:t>
+              <a:t>PD ≤ 1.21%</a:t>
             </a:r>
             <a:endParaRPr lang="en-US" sz="2200" dirty="0"/>
           </a:p>
@@ -8531,14 +8609,14 @@
       </p:sp>
       <p:sp>
         <p:nvSpPr>
-          <p:cNvPr id="10" name="Shape 8"/>
+          <p:cNvPr id="406" name="Banda0Shape10"/>
           <p:cNvSpPr/>
           <p:nvPr/>
         </p:nvSpPr>
         <p:spPr>
           <a:xfrm>
             <a:off x="822960" y="3611880"/>
-            <a:ext cx="3017520" cy="0"/>
+            <a:ext cx="2045970" cy="0"/>
           </a:xfrm>
           <a:prstGeom prst="line">
             <a:avLst/>
@@ -8561,14 +8639,14 @@
       </p:sp>
       <p:sp>
         <p:nvSpPr>
-          <p:cNvPr id="11" name="Text 9"/>
+          <p:cNvPr id="407" name="Banda0Shape11"/>
           <p:cNvSpPr/>
           <p:nvPr/>
         </p:nvSpPr>
         <p:spPr>
           <a:xfrm>
             <a:off x="822960" y="3749040"/>
-            <a:ext cx="3017520" cy="1371600"/>
+            <a:ext cx="2045970" cy="1371600"/>
           </a:xfrm>
           <a:prstGeom prst="rect">
             <a:avLst/>
@@ -8584,7 +8662,7 @@
               <a:buNone/>
             </a:pPr>
             <a:r>
-              <a:rPr lang="en-US" sz="1300" dirty="0">
+              <a:rPr lang="en-US" sz="1100" dirty="0">
                 <a:solidFill>
                   <a:srgbClr val="141A45"/>
                 </a:solidFill>
@@ -8600,14 +8678,14 @@
       </p:sp>
       <p:sp>
         <p:nvSpPr>
-          <p:cNvPr id="12" name="Shape 10"/>
-          <p:cNvSpPr/>
-          <p:nvPr/>
-        </p:nvSpPr>
-        <p:spPr>
-          <a:xfrm>
-            <a:off x="4343400" y="1737360"/>
-            <a:ext cx="3566160" cy="3566160"/>
+          <p:cNvPr id="408" name="Banda1Shape4"/>
+          <p:cNvSpPr/>
+          <p:nvPr/>
+        </p:nvSpPr>
+        <p:spPr>
+          <a:xfrm>
+            <a:off x="3371850" y="1737360"/>
+            <a:ext cx="2594610" cy="3566160"/>
           </a:xfrm>
           <a:prstGeom prst="roundRect">
             <a:avLst>
@@ -8641,13 +8719,13 @@
       </p:sp>
       <p:sp>
         <p:nvSpPr>
-          <p:cNvPr id="13" name="Shape 11"/>
-          <p:cNvSpPr/>
-          <p:nvPr/>
-        </p:nvSpPr>
-        <p:spPr>
-          <a:xfrm>
-            <a:off x="4617720" y="1965960"/>
+          <p:cNvPr id="409" name="Banda1Shape5"/>
+          <p:cNvSpPr/>
+          <p:nvPr/>
+        </p:nvSpPr>
+        <p:spPr>
+          <a:xfrm>
+            <a:off x="3646170" y="1965960"/>
             <a:ext cx="457200" cy="457200"/>
           </a:xfrm>
           <a:prstGeom prst="ellipse">
@@ -8668,13 +8746,13 @@
       </p:sp>
       <p:sp>
         <p:nvSpPr>
-          <p:cNvPr id="14" name="Text 12"/>
-          <p:cNvSpPr/>
-          <p:nvPr/>
-        </p:nvSpPr>
-        <p:spPr>
-          <a:xfrm>
-            <a:off x="4617720" y="1965960"/>
+          <p:cNvPr id="410" name="Banda1Shape6"/>
+          <p:cNvSpPr/>
+          <p:nvPr/>
+        </p:nvSpPr>
+        <p:spPr>
+          <a:xfrm>
+            <a:off x="3646170" y="1965960"/>
             <a:ext cx="457200" cy="457200"/>
           </a:xfrm>
           <a:prstGeom prst="rect">
@@ -8691,7 +8769,7 @@
               <a:buNone/>
             </a:pPr>
             <a:r>
-              <a:rPr lang="en-US" sz="1400" b="1" dirty="0">
+              <a:rPr lang="en-US" sz="1150" b="1" dirty="0">
                 <a:solidFill>
                   <a:srgbClr val="FFFFFF"/>
                 </a:solidFill>
@@ -8701,20 +8779,20 @@
               </a:rPr>
               <a:t>●</a:t>
             </a:r>
-            <a:endParaRPr lang="en-US" sz="1400" dirty="0"/>
-          </a:p>
-        </p:txBody>
-      </p:sp>
-      <p:sp>
-        <p:nvSpPr>
-          <p:cNvPr id="15" name="Text 13"/>
-          <p:cNvSpPr/>
-          <p:nvPr/>
-        </p:nvSpPr>
-        <p:spPr>
-          <a:xfrm>
-            <a:off x="5257800" y="2029968"/>
-            <a:ext cx="2377440" cy="365760"/>
+            <a:endParaRPr lang="en-US" sz="1150" dirty="0"/>
+          </a:p>
+        </p:txBody>
+      </p:sp>
+      <p:sp>
+        <p:nvSpPr>
+          <p:cNvPr id="411" name="Banda1Shape7"/>
+          <p:cNvSpPr/>
+          <p:nvPr/>
+        </p:nvSpPr>
+        <p:spPr>
+          <a:xfrm>
+            <a:off x="4286250" y="2029968"/>
+            <a:ext cx="1405890" cy="502920"/>
           </a:xfrm>
           <a:prstGeom prst="rect">
             <a:avLst/>
@@ -8730,7 +8808,7 @@
               <a:buNone/>
             </a:pPr>
             <a:r>
-              <a:rPr lang="en-US" sz="1700" b="1" dirty="0">
+              <a:rPr lang="en-US" sz="1150" b="1" dirty="0">
                 <a:solidFill>
                   <a:srgbClr val="1E2761"/>
                 </a:solidFill>
@@ -8738,7 +8816,7 @@
                 <a:ea typeface="Cambria" pitchFamily="34" charset="-122"/>
                 <a:cs typeface="Cambria" pitchFamily="34" charset="-120"/>
               </a:rPr>
-              <a:t>Riesgo Medio</a:t>
+              <a:t>Medio Riesgo</a:t>
             </a:r>
             <a:endParaRPr lang="en-US" sz="1700" dirty="0"/>
           </a:p>
@@ -8746,14 +8824,14 @@
       </p:sp>
       <p:sp>
         <p:nvSpPr>
-          <p:cNvPr id="16" name="Text 14"/>
-          <p:cNvSpPr/>
-          <p:nvPr/>
-        </p:nvSpPr>
-        <p:spPr>
-          <a:xfrm>
-            <a:off x="4617720" y="2606040"/>
-            <a:ext cx="3017520" cy="320040"/>
+          <p:cNvPr id="412" name="Banda1Shape8"/>
+          <p:cNvSpPr/>
+          <p:nvPr/>
+        </p:nvSpPr>
+        <p:spPr>
+          <a:xfrm>
+            <a:off x="3646170" y="2606040"/>
+            <a:ext cx="2045970" cy="320040"/>
           </a:xfrm>
           <a:prstGeom prst="rect">
             <a:avLst/>
@@ -8769,7 +8847,7 @@
               <a:buNone/>
             </a:pPr>
             <a:r>
-              <a:rPr lang="en-US" sz="1300" dirty="0">
+              <a:rPr lang="en-US" sz="1050" dirty="0">
                 <a:solidFill>
                   <a:srgbClr val="5B6584"/>
                 </a:solidFill>
@@ -8777,7 +8855,7 @@
                 <a:ea typeface="Calibri" pitchFamily="34" charset="-122"/>
                 <a:cs typeface="Calibri" pitchFamily="34" charset="-120"/>
               </a:rPr>
-              <a:t>620 – 699</a:t>
+              <a:t>Umbral de PD</a:t>
             </a:r>
             <a:endParaRPr lang="en-US" sz="1300" dirty="0"/>
           </a:p>
@@ -8785,14 +8863,14 @@
       </p:sp>
       <p:sp>
         <p:nvSpPr>
-          <p:cNvPr id="17" name="Text 15"/>
-          <p:cNvSpPr/>
-          <p:nvPr/>
-        </p:nvSpPr>
-        <p:spPr>
-          <a:xfrm>
-            <a:off x="4617720" y="2971800"/>
-            <a:ext cx="3017520" cy="502920"/>
+          <p:cNvPr id="413" name="Banda1Shape9"/>
+          <p:cNvSpPr/>
+          <p:nvPr/>
+        </p:nvSpPr>
+        <p:spPr>
+          <a:xfrm>
+            <a:off x="3646170" y="2971800"/>
+            <a:ext cx="2045970" cy="502920"/>
           </a:xfrm>
           <a:prstGeom prst="rect">
             <a:avLst/>
@@ -8808,7 +8886,7 @@
               <a:buNone/>
             </a:pPr>
             <a:r>
-              <a:rPr lang="en-US" sz="2200" b="1" dirty="0">
+              <a:rPr lang="en-US" sz="1800" b="1" dirty="0">
                 <a:solidFill>
                   <a:srgbClr val="C9A227"/>
                 </a:solidFill>
@@ -8816,7 +8894,7 @@
                 <a:ea typeface="Cambria" pitchFamily="34" charset="-122"/>
                 <a:cs typeface="Cambria" pitchFamily="34" charset="-120"/>
               </a:rPr>
-              <a:t>PD 2% – 8%</a:t>
+              <a:t>PD ≤ 3.1%</a:t>
             </a:r>
             <a:endParaRPr lang="en-US" sz="2200" dirty="0"/>
           </a:p>
@@ -8824,14 +8902,14 @@
       </p:sp>
       <p:sp>
         <p:nvSpPr>
-          <p:cNvPr id="18" name="Shape 16"/>
-          <p:cNvSpPr/>
-          <p:nvPr/>
-        </p:nvSpPr>
-        <p:spPr>
-          <a:xfrm>
-            <a:off x="4617720" y="3611880"/>
-            <a:ext cx="3017520" cy="0"/>
+          <p:cNvPr id="414" name="Banda1Shape10"/>
+          <p:cNvSpPr/>
+          <p:nvPr/>
+        </p:nvSpPr>
+        <p:spPr>
+          <a:xfrm>
+            <a:off x="3646170" y="3611880"/>
+            <a:ext cx="2045970" cy="0"/>
           </a:xfrm>
           <a:prstGeom prst="line">
             <a:avLst/>
@@ -8854,14 +8932,14 @@
       </p:sp>
       <p:sp>
         <p:nvSpPr>
-          <p:cNvPr id="19" name="Text 17"/>
-          <p:cNvSpPr/>
-          <p:nvPr/>
-        </p:nvSpPr>
-        <p:spPr>
-          <a:xfrm>
-            <a:off x="4617720" y="3749040"/>
-            <a:ext cx="3017520" cy="1371600"/>
+          <p:cNvPr id="415" name="Banda1Shape11"/>
+          <p:cNvSpPr/>
+          <p:nvPr/>
+        </p:nvSpPr>
+        <p:spPr>
+          <a:xfrm>
+            <a:off x="3646170" y="3749040"/>
+            <a:ext cx="2045970" cy="1371600"/>
           </a:xfrm>
           <a:prstGeom prst="rect">
             <a:avLst/>
@@ -8877,7 +8955,7 @@
               <a:buNone/>
             </a:pPr>
             <a:r>
-              <a:rPr lang="en-US" sz="1300" dirty="0">
+              <a:rPr lang="en-US" sz="1100" dirty="0">
                 <a:solidFill>
                   <a:srgbClr val="141A45"/>
                 </a:solidFill>
@@ -8893,14 +8971,14 @@
       </p:sp>
       <p:sp>
         <p:nvSpPr>
-          <p:cNvPr id="20" name="Shape 18"/>
-          <p:cNvSpPr/>
-          <p:nvPr/>
-        </p:nvSpPr>
-        <p:spPr>
-          <a:xfrm>
-            <a:off x="8138160" y="1737360"/>
-            <a:ext cx="3566160" cy="3566160"/>
+          <p:cNvPr id="416" name="Banda2Shape4"/>
+          <p:cNvSpPr/>
+          <p:nvPr/>
+        </p:nvSpPr>
+        <p:spPr>
+          <a:xfrm>
+            <a:off x="6195060" y="1737360"/>
+            <a:ext cx="2594610" cy="3566160"/>
           </a:xfrm>
           <a:prstGeom prst="roundRect">
             <a:avLst>
@@ -8934,20 +9012,20 @@
       </p:sp>
       <p:sp>
         <p:nvSpPr>
-          <p:cNvPr id="21" name="Shape 19"/>
-          <p:cNvSpPr/>
-          <p:nvPr/>
-        </p:nvSpPr>
-        <p:spPr>
-          <a:xfrm>
-            <a:off x="8412480" y="1965960"/>
+          <p:cNvPr id="417" name="Banda2Shape5"/>
+          <p:cNvSpPr/>
+          <p:nvPr/>
+        </p:nvSpPr>
+        <p:spPr>
+          <a:xfrm>
+            <a:off x="6469380" y="1965960"/>
             <a:ext cx="457200" cy="457200"/>
           </a:xfrm>
           <a:prstGeom prst="ellipse">
             <a:avLst/>
           </a:prstGeom>
           <a:solidFill>
-            <a:srgbClr val="B84C4C"/>
+            <a:srgbClr val="D97C3D"/>
           </a:solidFill>
           <a:ln/>
         </p:spPr>
@@ -8961,13 +9039,13 @@
       </p:sp>
       <p:sp>
         <p:nvSpPr>
-          <p:cNvPr id="22" name="Text 20"/>
-          <p:cNvSpPr/>
-          <p:nvPr/>
-        </p:nvSpPr>
-        <p:spPr>
-          <a:xfrm>
-            <a:off x="8412480" y="1965960"/>
+          <p:cNvPr id="418" name="Banda2Shape6"/>
+          <p:cNvSpPr/>
+          <p:nvPr/>
+        </p:nvSpPr>
+        <p:spPr>
+          <a:xfrm>
+            <a:off x="6469380" y="1965960"/>
             <a:ext cx="457200" cy="457200"/>
           </a:xfrm>
           <a:prstGeom prst="rect">
@@ -8984,7 +9062,7 @@
               <a:buNone/>
             </a:pPr>
             <a:r>
-              <a:rPr lang="en-US" sz="1400" b="1" dirty="0">
+              <a:rPr lang="en-US" sz="1150" b="1" dirty="0">
                 <a:solidFill>
                   <a:srgbClr val="FFFFFF"/>
                 </a:solidFill>
@@ -8994,20 +9072,20 @@
               </a:rPr>
               <a:t>●</a:t>
             </a:r>
-            <a:endParaRPr lang="en-US" sz="1400" dirty="0"/>
-          </a:p>
-        </p:txBody>
-      </p:sp>
-      <p:sp>
-        <p:nvSpPr>
-          <p:cNvPr id="23" name="Text 21"/>
-          <p:cNvSpPr/>
-          <p:nvPr/>
-        </p:nvSpPr>
-        <p:spPr>
-          <a:xfrm>
-            <a:off x="9052560" y="2029968"/>
-            <a:ext cx="2377440" cy="365760"/>
+            <a:endParaRPr lang="en-US" sz="1150" dirty="0"/>
+          </a:p>
+        </p:txBody>
+      </p:sp>
+      <p:sp>
+        <p:nvSpPr>
+          <p:cNvPr id="419" name="Banda2Shape7"/>
+          <p:cNvSpPr/>
+          <p:nvPr/>
+        </p:nvSpPr>
+        <p:spPr>
+          <a:xfrm>
+            <a:off x="7109460" y="2029968"/>
+            <a:ext cx="1405890" cy="502920"/>
           </a:xfrm>
           <a:prstGeom prst="rect">
             <a:avLst/>
@@ -9023,7 +9101,7 @@
               <a:buNone/>
             </a:pPr>
             <a:r>
-              <a:rPr lang="en-US" sz="1700" b="1" dirty="0">
+              <a:rPr lang="en-US" sz="1150" b="1" dirty="0">
                 <a:solidFill>
                   <a:srgbClr val="1E2761"/>
                 </a:solidFill>
@@ -9031,7 +9109,7 @@
                 <a:ea typeface="Cambria" pitchFamily="34" charset="-122"/>
                 <a:cs typeface="Cambria" pitchFamily="34" charset="-120"/>
               </a:rPr>
-              <a:t>Riesgo Alto</a:t>
+              <a:t>Alto Riesgo</a:t>
             </a:r>
             <a:endParaRPr lang="en-US" sz="1700" dirty="0"/>
           </a:p>
@@ -9039,14 +9117,14 @@
       </p:sp>
       <p:sp>
         <p:nvSpPr>
-          <p:cNvPr id="24" name="Text 22"/>
-          <p:cNvSpPr/>
-          <p:nvPr/>
-        </p:nvSpPr>
-        <p:spPr>
-          <a:xfrm>
-            <a:off x="8412480" y="2606040"/>
-            <a:ext cx="3017520" cy="320040"/>
+          <p:cNvPr id="420" name="Banda2Shape8"/>
+          <p:cNvSpPr/>
+          <p:nvPr/>
+        </p:nvSpPr>
+        <p:spPr>
+          <a:xfrm>
+            <a:off x="6469380" y="2606040"/>
+            <a:ext cx="2045970" cy="320040"/>
           </a:xfrm>
           <a:prstGeom prst="rect">
             <a:avLst/>
@@ -9062,7 +9140,7 @@
               <a:buNone/>
             </a:pPr>
             <a:r>
-              <a:rPr lang="en-US" sz="1300" dirty="0">
+              <a:rPr lang="en-US" sz="1050" dirty="0">
                 <a:solidFill>
                   <a:srgbClr val="5B6584"/>
                 </a:solidFill>
@@ -9070,7 +9148,7 @@
                 <a:ea typeface="Calibri" pitchFamily="34" charset="-122"/>
                 <a:cs typeface="Calibri" pitchFamily="34" charset="-120"/>
               </a:rPr>
-              <a:t>Score &lt; 620</a:t>
+              <a:t>Umbral de PD</a:t>
             </a:r>
             <a:endParaRPr lang="en-US" sz="1300" dirty="0"/>
           </a:p>
@@ -9078,14 +9156,14 @@
       </p:sp>
       <p:sp>
         <p:nvSpPr>
-          <p:cNvPr id="25" name="Text 23"/>
-          <p:cNvSpPr/>
-          <p:nvPr/>
-        </p:nvSpPr>
-        <p:spPr>
-          <a:xfrm>
-            <a:off x="8412480" y="2971800"/>
-            <a:ext cx="3017520" cy="502920"/>
+          <p:cNvPr id="421" name="Banda2Shape9"/>
+          <p:cNvSpPr/>
+          <p:nvPr/>
+        </p:nvSpPr>
+        <p:spPr>
+          <a:xfrm>
+            <a:off x="6469380" y="2971800"/>
+            <a:ext cx="2045970" cy="502920"/>
           </a:xfrm>
           <a:prstGeom prst="rect">
             <a:avLst/>
@@ -9101,15 +9179,15 @@
               <a:buNone/>
             </a:pPr>
             <a:r>
-              <a:rPr lang="en-US" sz="2200" b="1" dirty="0">
-                <a:solidFill>
-                  <a:srgbClr val="B84C4C"/>
+              <a:rPr lang="en-US" sz="1800" b="1" dirty="0">
+                <a:solidFill>
+                  <a:srgbClr val="D97C3D"/>
                 </a:solidFill>
                 <a:latin typeface="Cambria" pitchFamily="34" charset="0"/>
                 <a:ea typeface="Cambria" pitchFamily="34" charset="-122"/>
                 <a:cs typeface="Cambria" pitchFamily="34" charset="-120"/>
               </a:rPr>
-              <a:t>PD &gt; 8%</a:t>
+              <a:t>PD ≤ 16.7%</a:t>
             </a:r>
             <a:endParaRPr lang="en-US" sz="2200" dirty="0"/>
           </a:p>
@@ -9117,14 +9195,14 @@
       </p:sp>
       <p:sp>
         <p:nvSpPr>
-          <p:cNvPr id="26" name="Shape 24"/>
-          <p:cNvSpPr/>
-          <p:nvPr/>
-        </p:nvSpPr>
-        <p:spPr>
-          <a:xfrm>
-            <a:off x="8412480" y="3611880"/>
-            <a:ext cx="3017520" cy="0"/>
+          <p:cNvPr id="422" name="Banda2Shape10"/>
+          <p:cNvSpPr/>
+          <p:nvPr/>
+        </p:nvSpPr>
+        <p:spPr>
+          <a:xfrm>
+            <a:off x="6469380" y="3611880"/>
+            <a:ext cx="2045970" cy="0"/>
           </a:xfrm>
           <a:prstGeom prst="line">
             <a:avLst/>
@@ -9147,14 +9225,14 @@
       </p:sp>
       <p:sp>
         <p:nvSpPr>
-          <p:cNvPr id="27" name="Text 25"/>
-          <p:cNvSpPr/>
-          <p:nvPr/>
-        </p:nvSpPr>
-        <p:spPr>
-          <a:xfrm>
-            <a:off x="8412480" y="3749040"/>
-            <a:ext cx="3017520" cy="1371600"/>
+          <p:cNvPr id="423" name="Banda2Shape11"/>
+          <p:cNvSpPr/>
+          <p:nvPr/>
+        </p:nvSpPr>
+        <p:spPr>
+          <a:xfrm>
+            <a:off x="6469380" y="3749040"/>
+            <a:ext cx="2045970" cy="1371600"/>
           </a:xfrm>
           <a:prstGeom prst="rect">
             <a:avLst/>
@@ -9170,7 +9248,7 @@
               <a:buNone/>
             </a:pPr>
             <a:r>
-              <a:rPr lang="en-US" sz="1300" dirty="0">
+              <a:rPr lang="en-US" sz="1100" dirty="0">
                 <a:solidFill>
                   <a:srgbClr val="141A45"/>
                 </a:solidFill>
@@ -9178,7 +9256,7 @@
                 <a:ea typeface="Calibri" pitchFamily="34" charset="-122"/>
                 <a:cs typeface="Calibri" pitchFamily="34" charset="-120"/>
               </a:rPr>
-              <a:t>Rechazo o garantías adicionales</a:t>
+              <a:t>Garantías adicionales o repricing (aún rentable: ROA 12.9%)</a:t>
             </a:r>
             <a:endParaRPr lang="en-US" sz="1300" dirty="0"/>
           </a:p>
@@ -9186,53 +9264,121 @@
       </p:sp>
       <p:sp>
         <p:nvSpPr>
-          <p:cNvPr id="28" name="Text 26"/>
-          <p:cNvSpPr/>
-          <p:nvPr/>
-        </p:nvSpPr>
-        <p:spPr>
-          <a:xfrm>
-            <a:off x="548640" y="5486400"/>
-            <a:ext cx="11064240" cy="457200"/>
-          </a:xfrm>
-          <a:prstGeom prst="rect">
-            <a:avLst/>
-          </a:prstGeom>
-          <a:noFill/>
-          <a:ln/>
-        </p:spPr>
-        <p:txBody>
-          <a:bodyPr wrap="square" lIns="0" tIns="0" rIns="0" bIns="0" rtlCol="0" anchor="ctr"/>
-          <a:lstStyle/>
-          <a:p>
-            <a:pPr marL="0" indent="0">
-              <a:buNone/>
-            </a:pPr>
-            <a:r>
-              <a:rPr lang="en-US" sz="1200" i="1" dirty="0">
-                <a:solidFill>
-                  <a:srgbClr val="5B6584"/>
+          <p:cNvPr id="424" name="Banda3Shape4"/>
+          <p:cNvSpPr/>
+          <p:nvPr/>
+        </p:nvSpPr>
+        <p:spPr>
+          <a:xfrm>
+            <a:off x="9018270" y="1737360"/>
+            <a:ext cx="2594610" cy="3566160"/>
+          </a:xfrm>
+          <a:prstGeom prst="roundRect">
+            <a:avLst>
+              <a:gd name="adj" fmla="val 2051"/>
+            </a:avLst>
+          </a:prstGeom>
+          <a:solidFill>
+            <a:srgbClr val="FFFFFF"/>
+          </a:solidFill>
+          <a:ln w="12700">
+            <a:solidFill>
+              <a:srgbClr val="E2E7F2"/>
+            </a:solidFill>
+            <a:prstDash val="solid"/>
+          </a:ln>
+          <a:effectLst>
+            <a:outerShdw blurRad="76200" dist="25400" dir="5400000" algn="bl" rotWithShape="0">
+              <a:srgbClr val="1E2761">
+                <a:alpha val="10000"/>
+              </a:srgbClr>
+            </a:outerShdw>
+          </a:effectLst>
+        </p:spPr>
+        <p:txBody>
+          <a:bodyPr/>
+          <a:lstStyle/>
+          <a:p>
+            <a:endParaRPr lang="en-PE"/>
+          </a:p>
+        </p:txBody>
+      </p:sp>
+      <p:sp>
+        <p:nvSpPr>
+          <p:cNvPr id="425" name="Banda3Shape5"/>
+          <p:cNvSpPr/>
+          <p:nvPr/>
+        </p:nvSpPr>
+        <p:spPr>
+          <a:xfrm>
+            <a:off x="9292590" y="1965960"/>
+            <a:ext cx="457200" cy="457200"/>
+          </a:xfrm>
+          <a:prstGeom prst="ellipse">
+            <a:avLst/>
+          </a:prstGeom>
+          <a:solidFill>
+            <a:srgbClr val="B84C4C"/>
+          </a:solidFill>
+          <a:ln/>
+        </p:spPr>
+        <p:txBody>
+          <a:bodyPr/>
+          <a:lstStyle/>
+          <a:p>
+            <a:endParaRPr lang="en-PE"/>
+          </a:p>
+        </p:txBody>
+      </p:sp>
+      <p:sp>
+        <p:nvSpPr>
+          <p:cNvPr id="426" name="Banda3Shape6"/>
+          <p:cNvSpPr/>
+          <p:nvPr/>
+        </p:nvSpPr>
+        <p:spPr>
+          <a:xfrm>
+            <a:off x="9292590" y="1965960"/>
+            <a:ext cx="457200" cy="457200"/>
+          </a:xfrm>
+          <a:prstGeom prst="rect">
+            <a:avLst/>
+          </a:prstGeom>
+          <a:noFill/>
+          <a:ln/>
+        </p:spPr>
+        <p:txBody>
+          <a:bodyPr wrap="square" lIns="0" tIns="0" rIns="0" bIns="0" rtlCol="0" anchor="ctr"/>
+          <a:lstStyle/>
+          <a:p>
+            <a:pPr marL="0" indent="0" algn="ctr">
+              <a:buNone/>
+            </a:pPr>
+            <a:r>
+              <a:rPr lang="en-US" sz="1150" b="1" dirty="0">
+                <a:solidFill>
+                  <a:srgbClr val="FFFFFF"/>
                 </a:solidFill>
                 <a:latin typeface="Calibri" pitchFamily="34" charset="0"/>
                 <a:ea typeface="Calibri" pitchFamily="34" charset="-122"/>
                 <a:cs typeface="Calibri" pitchFamily="34" charset="-120"/>
               </a:rPr>
-              <a:t>El cutoff óptimo se define junto con negocio, balanceando tasa de aprobación vs. mora esperada (ver simulación de escenarios).</a:t>
-            </a:r>
-            <a:endParaRPr lang="en-US" sz="1200" dirty="0"/>
-          </a:p>
-        </p:txBody>
-      </p:sp>
-      <p:sp>
-        <p:nvSpPr>
-          <p:cNvPr id="29" name="Text 27"/>
-          <p:cNvSpPr/>
-          <p:nvPr/>
-        </p:nvSpPr>
-        <p:spPr>
-          <a:xfrm>
-            <a:off x="457200" y="6537960"/>
-            <a:ext cx="7315200" cy="274320"/>
+              <a:t>●</a:t>
+            </a:r>
+            <a:endParaRPr lang="en-US" sz="1150" dirty="0"/>
+          </a:p>
+        </p:txBody>
+      </p:sp>
+      <p:sp>
+        <p:nvSpPr>
+          <p:cNvPr id="427" name="Banda3Shape7"/>
+          <p:cNvSpPr/>
+          <p:nvPr/>
+        </p:nvSpPr>
+        <p:spPr>
+          <a:xfrm>
+            <a:off x="9932670" y="2029968"/>
+            <a:ext cx="1405890" cy="502920"/>
           </a:xfrm>
           <a:prstGeom prst="rect">
             <a:avLst/>
@@ -9248,7 +9394,46 @@
               <a:buNone/>
             </a:pPr>
             <a:r>
-              <a:rPr lang="en-US" sz="900" i="1" dirty="0">
+              <a:rPr lang="en-US" sz="1150" b="1" dirty="0">
+                <a:solidFill>
+                  <a:srgbClr val="1E2761"/>
+                </a:solidFill>
+                <a:latin typeface="Cambria" pitchFamily="34" charset="0"/>
+                <a:ea typeface="Cambria" pitchFamily="34" charset="-122"/>
+                <a:cs typeface="Cambria" pitchFamily="34" charset="-120"/>
+              </a:rPr>
+              <a:t>Muy Alto Riesgo</a:t>
+            </a:r>
+            <a:endParaRPr lang="en-US" sz="1700" dirty="0"/>
+          </a:p>
+        </p:txBody>
+      </p:sp>
+      <p:sp>
+        <p:nvSpPr>
+          <p:cNvPr id="428" name="Banda3Shape8"/>
+          <p:cNvSpPr/>
+          <p:nvPr/>
+        </p:nvSpPr>
+        <p:spPr>
+          <a:xfrm>
+            <a:off x="9292590" y="2606040"/>
+            <a:ext cx="2045970" cy="320040"/>
+          </a:xfrm>
+          <a:prstGeom prst="rect">
+            <a:avLst/>
+          </a:prstGeom>
+          <a:noFill/>
+          <a:ln/>
+        </p:spPr>
+        <p:txBody>
+          <a:bodyPr wrap="square" lIns="0" tIns="0" rIns="0" bIns="0" rtlCol="0" anchor="ctr"/>
+          <a:lstStyle/>
+          <a:p>
+            <a:pPr marL="0" indent="0">
+              <a:buNone/>
+            </a:pPr>
+            <a:r>
+              <a:rPr lang="en-US" sz="1050" dirty="0">
                 <a:solidFill>
                   <a:srgbClr val="5B6584"/>
                 </a:solidFill>
@@ -9256,48 +9441,117 @@
                 <a:ea typeface="Calibri" pitchFamily="34" charset="-122"/>
                 <a:cs typeface="Calibri" pitchFamily="34" charset="-120"/>
               </a:rPr>
-              <a:t>Give Me Credit — Modelo de Scoring de Riesgo Crediticio</a:t>
-            </a:r>
-            <a:endParaRPr lang="en-US" sz="900" dirty="0"/>
-          </a:p>
-        </p:txBody>
-      </p:sp>
-      <p:sp>
-        <p:nvSpPr>
-          <p:cNvPr id="30" name="Text 28"/>
-          <p:cNvSpPr/>
-          <p:nvPr/>
-        </p:nvSpPr>
-        <p:spPr>
-          <a:xfrm>
-            <a:off x="11521440" y="6537960"/>
-            <a:ext cx="365760" cy="274320"/>
-          </a:xfrm>
-          <a:prstGeom prst="rect">
-            <a:avLst/>
-          </a:prstGeom>
-          <a:noFill/>
-          <a:ln/>
-        </p:spPr>
-        <p:txBody>
-          <a:bodyPr wrap="square" lIns="0" tIns="0" rIns="0" bIns="0" rtlCol="0" anchor="ctr"/>
-          <a:lstStyle/>
-          <a:p>
-            <a:pPr marL="0" indent="0" algn="r">
-              <a:buNone/>
-            </a:pPr>
-            <a:r>
-              <a:rPr lang="en-US" sz="900" dirty="0">
-                <a:solidFill>
-                  <a:srgbClr val="5B6584"/>
+              <a:t>Umbral de PD</a:t>
+            </a:r>
+            <a:endParaRPr lang="en-US" sz="1300" dirty="0"/>
+          </a:p>
+        </p:txBody>
+      </p:sp>
+      <p:sp>
+        <p:nvSpPr>
+          <p:cNvPr id="429" name="Banda3Shape9"/>
+          <p:cNvSpPr/>
+          <p:nvPr/>
+        </p:nvSpPr>
+        <p:spPr>
+          <a:xfrm>
+            <a:off x="9292590" y="2971800"/>
+            <a:ext cx="2045970" cy="502920"/>
+          </a:xfrm>
+          <a:prstGeom prst="rect">
+            <a:avLst/>
+          </a:prstGeom>
+          <a:noFill/>
+          <a:ln/>
+        </p:spPr>
+        <p:txBody>
+          <a:bodyPr wrap="square" lIns="0" tIns="0" rIns="0" bIns="0" rtlCol="0" anchor="ctr"/>
+          <a:lstStyle/>
+          <a:p>
+            <a:pPr marL="0" indent="0">
+              <a:buNone/>
+            </a:pPr>
+            <a:r>
+              <a:rPr lang="en-US" sz="1800" b="1" dirty="0">
+                <a:solidFill>
+                  <a:srgbClr val="B84C4C"/>
+                </a:solidFill>
+                <a:latin typeface="Cambria" pitchFamily="34" charset="0"/>
+                <a:ea typeface="Cambria" pitchFamily="34" charset="-122"/>
+                <a:cs typeface="Cambria" pitchFamily="34" charset="-120"/>
+              </a:rPr>
+              <a:t>PD &gt; 16.7%</a:t>
+            </a:r>
+            <a:endParaRPr lang="en-US" sz="2200" dirty="0"/>
+          </a:p>
+        </p:txBody>
+      </p:sp>
+      <p:sp>
+        <p:nvSpPr>
+          <p:cNvPr id="430" name="Banda3Shape10"/>
+          <p:cNvSpPr/>
+          <p:nvPr/>
+        </p:nvSpPr>
+        <p:spPr>
+          <a:xfrm>
+            <a:off x="9292590" y="3611880"/>
+            <a:ext cx="2045970" cy="0"/>
+          </a:xfrm>
+          <a:prstGeom prst="line">
+            <a:avLst/>
+          </a:prstGeom>
+          <a:noFill/>
+          <a:ln w="12700">
+            <a:solidFill>
+              <a:srgbClr val="E2E7F2"/>
+            </a:solidFill>
+            <a:prstDash val="solid"/>
+          </a:ln>
+        </p:spPr>
+        <p:txBody>
+          <a:bodyPr/>
+          <a:lstStyle/>
+          <a:p>
+            <a:endParaRPr lang="en-PE"/>
+          </a:p>
+        </p:txBody>
+      </p:sp>
+      <p:sp>
+        <p:nvSpPr>
+          <p:cNvPr id="431" name="Banda3Shape11"/>
+          <p:cNvSpPr/>
+          <p:nvPr/>
+        </p:nvSpPr>
+        <p:spPr>
+          <a:xfrm>
+            <a:off x="9292590" y="3749040"/>
+            <a:ext cx="2045970" cy="1371600"/>
+          </a:xfrm>
+          <a:prstGeom prst="rect">
+            <a:avLst/>
+          </a:prstGeom>
+          <a:noFill/>
+          <a:ln/>
+        </p:spPr>
+        <p:txBody>
+          <a:bodyPr wrap="square" lIns="0" tIns="0" rIns="0" bIns="0" rtlCol="0" anchor="ctr"/>
+          <a:lstStyle/>
+          <a:p>
+            <a:pPr marL="0" indent="0">
+              <a:buNone/>
+            </a:pPr>
+            <a:r>
+              <a:rPr lang="en-US" sz="1100" dirty="0">
+                <a:solidFill>
+                  <a:srgbClr val="141A45"/>
                 </a:solidFill>
                 <a:latin typeface="Calibri" pitchFamily="34" charset="0"/>
                 <a:ea typeface="Calibri" pitchFamily="34" charset="-122"/>
                 <a:cs typeface="Calibri" pitchFamily="34" charset="-120"/>
               </a:rPr>
-              <a:t>14</a:t>
-            </a:r>
-            <a:endParaRPr lang="en-US" sz="900" dirty="0"/>
+              <a:t>Rechazo (único segmento no rentable: ROA -3.9%)</a:t>
+            </a:r>
+            <a:endParaRPr lang="en-US" sz="1300" dirty="0"/>
           </a:p>
         </p:txBody>
       </p:sp>
@@ -9940,7 +10194,7 @@
                 <a:ea typeface="Cambria" pitchFamily="34" charset="-122"/>
                 <a:cs typeface="Cambria" pitchFamily="34" charset="-120"/>
               </a:rPr>
-              <a:t>Carga de deuda vs. ingreso</a:t>
+              <a:t>Edad del cliente</a:t>
             </a:r>
             <a:endParaRPr lang="en-US" sz="1350" dirty="0"/>
           </a:p>
@@ -9979,7 +10233,7 @@
                 <a:ea typeface="Calibri" pitchFamily="34" charset="-122"/>
                 <a:cs typeface="Calibri" pitchFamily="34" charset="-120"/>
               </a:rPr>
-              <a:t>A mayor proporción del ingreso comprometida en deuda, mayor probabilidad de incumplimiento.</a:t>
+              <a:t>Los segmentos más jóvenes muestran mayor riesgo relativo, probablemente por menor historial crediticio.</a:t>
             </a:r>
             <a:endParaRPr lang="en-US" sz="1200" dirty="0"/>
           </a:p>
@@ -10118,7 +10372,7 @@
                 <a:ea typeface="Cambria" pitchFamily="34" charset="-122"/>
                 <a:cs typeface="Cambria" pitchFamily="34" charset="-120"/>
               </a:rPr>
-              <a:t>Edad del cliente</a:t>
+              <a:t>Carga de deuda vs. ingreso</a:t>
             </a:r>
             <a:endParaRPr lang="en-US" sz="1350" dirty="0"/>
           </a:p>
@@ -10157,7 +10411,7 @@
                 <a:ea typeface="Calibri" pitchFamily="34" charset="-122"/>
                 <a:cs typeface="Calibri" pitchFamily="34" charset="-120"/>
               </a:rPr>
-              <a:t>Los segmentos más jóvenes muestran mayor riesgo relativo, probablemente por menor historial crediticio.</a:t>
+              <a:t>A mayor proporción del ingreso comprometida en deuda, mayor probabilidad de incumplimiento.</a:t>
             </a:r>
             <a:endParaRPr lang="en-US" sz="1200" dirty="0"/>
           </a:p>
@@ -10426,7 +10680,7 @@
                 <a:ea typeface="Cambria" pitchFamily="34" charset="-122"/>
                 <a:cs typeface="Cambria" pitchFamily="34" charset="-120"/>
               </a:rPr>
-              <a:t>+0.35 p.p.</a:t>
+              <a:t>7.18%</a:t>
             </a:r>
             <a:endParaRPr lang="en-US" sz="3200" dirty="0"/>
           </a:p>
@@ -10465,7 +10719,7 @@
                 <a:ea typeface="Calibri" pitchFamily="34" charset="-122"/>
                 <a:cs typeface="Calibri" pitchFamily="34" charset="-120"/>
               </a:rPr>
-              <a:t>Mejora estimada en ROA de la cartera</a:t>
+              <a:t>ROA de cartera (ponderado, real)</a:t>
             </a:r>
             <a:endParaRPr lang="en-US" sz="1200" dirty="0"/>
           </a:p>
@@ -10545,7 +10799,7 @@
                 <a:ea typeface="Cambria" pitchFamily="34" charset="-122"/>
                 <a:cs typeface="Cambria" pitchFamily="34" charset="-120"/>
               </a:rPr>
-              <a:t>-18%</a:t>
+              <a:t>91.6%</a:t>
             </a:r>
             <a:endParaRPr lang="en-US" sz="3200" dirty="0"/>
           </a:p>
@@ -10584,7 +10838,7 @@
                 <a:ea typeface="Calibri" pitchFamily="34" charset="-122"/>
                 <a:cs typeface="Calibri" pitchFamily="34" charset="-120"/>
               </a:rPr>
-              <a:t>Reducción de pérdida esperada vs. política actual</a:t>
+              <a:t>de la cartera en bandas rentables (Bajo + Medio + Alto)</a:t>
             </a:r>
             <a:endParaRPr lang="en-US" sz="1200" dirty="0"/>
           </a:p>
@@ -10658,13 +10912,13 @@
             <a:r>
               <a:rPr lang="en-US" sz="3200" b="1" dirty="0">
                 <a:solidFill>
-                  <a:srgbClr val="C9A227"/>
+                  <a:srgbClr val="B84C4C"/>
                 </a:solidFill>
                 <a:latin typeface="Cambria" pitchFamily="34" charset="0"/>
                 <a:ea typeface="Cambria" pitchFamily="34" charset="-122"/>
                 <a:cs typeface="Cambria" pitchFamily="34" charset="-120"/>
               </a:rPr>
-              <a:t>+6%</a:t>
+              <a:t>-3.9%</a:t>
             </a:r>
             <a:endParaRPr lang="en-US" sz="3200" dirty="0"/>
           </a:p>
@@ -10703,7 +10957,7 @@
                 <a:ea typeface="Calibri" pitchFamily="34" charset="-122"/>
                 <a:cs typeface="Calibri" pitchFamily="34" charset="-120"/>
               </a:rPr>
-              <a:t>Clientes buenos adicionales aprobados</a:t>
+              <a:t>ROA de Muy Alto Riesgo — único segmento no rentable</a:t>
             </a:r>
             <a:endParaRPr lang="en-US" sz="1200" dirty="0"/>
           </a:p>
@@ -10826,7 +11080,7 @@
                 <a:ea typeface="Calibri" pitchFamily="34" charset="-122"/>
                 <a:cs typeface="Calibri" pitchFamily="34" charset="-120"/>
               </a:rPr>
-              <a:t>Ingresos por intereses y comisiones, menos pérdida esperada (PD × LGD × EAD) y costo de capital, sobre el total de activos de la cartera simulada bajo el nuevo cutoff.</a:t>
+              <a:t>Ingresos por intereses y comisiones, menos pérdida esperada (PD × LGD × EAD) y costo de capital, sobre la cartera real segmentada en las 4 bandas de riesgo del modelo (gestion_portafolio(), 04_model_evaluation.ipynb).</a:t>
             </a:r>
             <a:endParaRPr lang="en-US" sz="1200" dirty="0"/>
           </a:p>
@@ -11015,7 +11269,7 @@
                 <a:ea typeface="Cambria" pitchFamily="34" charset="-122"/>
                 <a:cs typeface="Cambria" pitchFamily="34" charset="-120"/>
               </a:rPr>
-              <a:t>Simulación de escenarios de cutoff</a:t>
+              <a:t>Economía de cartera por banda de riesgo</a:t>
             </a:r>
             <a:endParaRPr lang="en-US" sz="3200" dirty="0"/>
           </a:p>
@@ -11054,7 +11308,7 @@
                 <a:ea typeface="Calibri" pitchFamily="34" charset="-122"/>
                 <a:cs typeface="Calibri" pitchFamily="34" charset="-120"/>
               </a:rPr>
-              <a:t>El trade-off central para negocio: aprobación vs. mora esperada vs. ROA, según dónde se fije el cutoff.</a:t>
+              <a:t>Participación, tasa activa, ROA y utilidad neta reales de las 4 bandas de riesgo — la base con la que se validaron los thresholds del modelo en producción.</a:t>
             </a:r>
             <a:endParaRPr lang="en-US" sz="1250" dirty="0"/>
           </a:p>
@@ -11066,13 +11320,7 @@
           <p:cNvGraphicFramePr>
             <a:graphicFrameLocks noGrp="1"/>
           </p:cNvGraphicFramePr>
-          <p:nvPr>
-            <p:extLst>
-              <p:ext uri="{D42A27DB-BD31-4B8C-83A1-F6EECF244321}">
-                <p14:modId xmlns:p14="http://schemas.microsoft.com/office/powerpoint/2010/main" val="1579011935"/>
-              </p:ext>
-            </p:extLst>
-          </p:nvPr>
+          <p:nvPr/>
         </p:nvGraphicFramePr>
         <p:xfrm>
           <a:off x="548640" y="1965960"/>
@@ -11083,53 +11331,23 @@
             <a:tbl>
               <a:tblPr/>
               <a:tblGrid>
-                <a:gridCol w="2468880">
-                  <a:extLst>
-                    <a:ext uri="{9D8B030D-6E8A-4147-A177-3AD203B41FA5}">
-                      <a16:colId xmlns:a16="http://schemas.microsoft.com/office/drawing/2014/main" val="20000"/>
-                    </a:ext>
-                  </a:extLst>
-                </a:gridCol>
-                <a:gridCol w="2148840">
-                  <a:extLst>
-                    <a:ext uri="{9D8B030D-6E8A-4147-A177-3AD203B41FA5}">
-                      <a16:colId xmlns:a16="http://schemas.microsoft.com/office/drawing/2014/main" val="20001"/>
-                    </a:ext>
-                  </a:extLst>
-                </a:gridCol>
-                <a:gridCol w="2148840">
-                  <a:extLst>
-                    <a:ext uri="{9D8B030D-6E8A-4147-A177-3AD203B41FA5}">
-                      <a16:colId xmlns:a16="http://schemas.microsoft.com/office/drawing/2014/main" val="20002"/>
-                    </a:ext>
-                  </a:extLst>
-                </a:gridCol>
-                <a:gridCol w="2148840">
-                  <a:extLst>
-                    <a:ext uri="{9D8B030D-6E8A-4147-A177-3AD203B41FA5}">
-                      <a16:colId xmlns:a16="http://schemas.microsoft.com/office/drawing/2014/main" val="20003"/>
-                    </a:ext>
-                  </a:extLst>
-                </a:gridCol>
-                <a:gridCol w="2148840">
-                  <a:extLst>
-                    <a:ext uri="{9D8B030D-6E8A-4147-A177-3AD203B41FA5}">
-                      <a16:colId xmlns:a16="http://schemas.microsoft.com/office/drawing/2014/main" val="20004"/>
-                    </a:ext>
-                  </a:extLst>
-                </a:gridCol>
+                <a:gridCol w="2468880"/>
+                <a:gridCol w="2148840"/>
+                <a:gridCol w="2148840"/>
+                <a:gridCol w="2148840"/>
+                <a:gridCol w="2148840"/>
               </a:tblGrid>
-              <a:tr h="548640">
+              <a:tr h="438912">
                 <a:tc>
                   <a:txBody>
                     <a:bodyPr/>
                     <a:lstStyle/>
                     <a:p>
-                      <a:pPr marL="0" indent="0" algn="ctr">
+                      <a:pPr marL="0" indent="0" algn="l">
                         <a:buNone/>
                       </a:pPr>
                       <a:r>
-                        <a:rPr lang="en-US" sz="1250" b="1" dirty="0">
+                        <a:rPr lang="en-US" sz="1150" b="1" dirty="0">
                           <a:solidFill>
                             <a:srgbClr val="FFFFFF"/>
                           </a:solidFill>
@@ -11137,9 +11355,9 @@
                           <a:ea typeface="Calibri" pitchFamily="34" charset="-122"/>
                           <a:cs typeface="Calibri" pitchFamily="34" charset="-120"/>
                         </a:rPr>
-                        <a:t>Escenario</a:t>
+                        <a:t>Banda</a:t>
                       </a:r>
-                      <a:endParaRPr lang="en-US" sz="1250" dirty="0">
+                      <a:endParaRPr lang="en-US" sz="1150" dirty="0">
                         <a:latin typeface="Calibri" charset="0"/>
                         <a:ea typeface="Calibri" charset="0"/>
                         <a:cs typeface="Calibri" charset="0"/>
@@ -11197,7 +11415,7 @@
                         <a:buNone/>
                       </a:pPr>
                       <a:r>
-                        <a:rPr lang="en-US" sz="1250" b="1" dirty="0">
+                        <a:rPr lang="en-US" sz="1150" b="1" dirty="0">
                           <a:solidFill>
                             <a:srgbClr val="FFFFFF"/>
                           </a:solidFill>
@@ -11205,9 +11423,9 @@
                           <a:ea typeface="Calibri" pitchFamily="34" charset="-122"/>
                           <a:cs typeface="Calibri" pitchFamily="34" charset="-120"/>
                         </a:rPr>
-                        <a:t>Cutoff (score)</a:t>
+                        <a:t>Participación %</a:t>
                       </a:r>
-                      <a:endParaRPr lang="en-US" sz="1250" dirty="0">
+                      <a:endParaRPr lang="en-US" sz="1150" dirty="0">
                         <a:latin typeface="Calibri" charset="0"/>
                         <a:ea typeface="Calibri" charset="0"/>
                         <a:cs typeface="Calibri" charset="0"/>
@@ -11265,7 +11483,7 @@
                         <a:buNone/>
                       </a:pPr>
                       <a:r>
-                        <a:rPr lang="en-US" sz="1250" b="1" dirty="0">
+                        <a:rPr lang="en-US" sz="1150" b="1" dirty="0">
                           <a:solidFill>
                             <a:srgbClr val="FFFFFF"/>
                           </a:solidFill>
@@ -11273,9 +11491,9 @@
                           <a:ea typeface="Calibri" pitchFamily="34" charset="-122"/>
                           <a:cs typeface="Calibri" pitchFamily="34" charset="-120"/>
                         </a:rPr>
-                        <a:t>Tasa de aprobación</a:t>
+                        <a:t>Tasa activa %</a:t>
                       </a:r>
-                      <a:endParaRPr lang="en-US" sz="1250" dirty="0">
+                      <a:endParaRPr lang="en-US" sz="1150" dirty="0">
                         <a:latin typeface="Calibri" charset="0"/>
                         <a:ea typeface="Calibri" charset="0"/>
                         <a:cs typeface="Calibri" charset="0"/>
@@ -11333,7 +11551,7 @@
                         <a:buNone/>
                       </a:pPr>
                       <a:r>
-                        <a:rPr lang="en-US" sz="1250" b="1" dirty="0">
+                        <a:rPr lang="en-US" sz="1150" b="1" dirty="0">
                           <a:solidFill>
                             <a:srgbClr val="FFFFFF"/>
                           </a:solidFill>
@@ -11341,9 +11559,9 @@
                           <a:ea typeface="Calibri" pitchFamily="34" charset="-122"/>
                           <a:cs typeface="Calibri" pitchFamily="34" charset="-120"/>
                         </a:rPr>
-                        <a:t>Mora esperada</a:t>
+                        <a:t>ROA %</a:t>
                       </a:r>
-                      <a:endParaRPr lang="en-US" sz="1250" dirty="0">
+                      <a:endParaRPr lang="en-US" sz="1150" dirty="0">
                         <a:latin typeface="Calibri" charset="0"/>
                         <a:ea typeface="Calibri" charset="0"/>
                         <a:cs typeface="Calibri" charset="0"/>
@@ -11401,7 +11619,7 @@
                         <a:buNone/>
                       </a:pPr>
                       <a:r>
-                        <a:rPr lang="en-US" sz="1250" b="1" dirty="0">
+                        <a:rPr lang="en-US" sz="1150" b="1" dirty="0">
                           <a:solidFill>
                             <a:srgbClr val="FFFFFF"/>
                           </a:solidFill>
@@ -11409,9 +11627,9 @@
                           <a:ea typeface="Calibri" pitchFamily="34" charset="-122"/>
                           <a:cs typeface="Calibri" pitchFamily="34" charset="-120"/>
                         </a:rPr>
-                        <a:t>ROA estimado</a:t>
+                        <a:t>Utilidad neta</a:t>
                       </a:r>
-                      <a:endParaRPr lang="en-US" sz="1250" dirty="0">
+                      <a:endParaRPr lang="en-US" sz="1150" dirty="0">
                         <a:latin typeface="Calibri" charset="0"/>
                         <a:ea typeface="Calibri" charset="0"/>
                         <a:cs typeface="Calibri" charset="0"/>
@@ -11460,13 +11678,8 @@
                     </a:solidFill>
                   </a:tcPr>
                 </a:tc>
-                <a:extLst>
-                  <a:ext uri="{0D108BD9-81ED-4DB2-BD59-A6C34878D82A}">
-                    <a16:rowId xmlns:a16="http://schemas.microsoft.com/office/drawing/2014/main" val="10000"/>
-                  </a:ext>
-                </a:extLst>
               </a:tr>
-              <a:tr h="548640">
+              <a:tr h="438912">
                 <a:tc>
                   <a:txBody>
                     <a:bodyPr/>
@@ -11476,7 +11689,7 @@
                         <a:buNone/>
                       </a:pPr>
                       <a:r>
-                        <a:rPr lang="en-US" sz="1300" b="1" dirty="0">
+                        <a:rPr lang="en-US" sz="1150" b="1" dirty="0">
                           <a:solidFill>
                             <a:srgbClr val="141A45"/>
                           </a:solidFill>
@@ -11484,9 +11697,351 @@
                           <a:ea typeface="Calibri" pitchFamily="34" charset="-122"/>
                           <a:cs typeface="Calibri" pitchFamily="34" charset="-120"/>
                         </a:rPr>
-                        <a:t>Conservador</a:t>
+                        <a:t>Bajo Riesgo</a:t>
                       </a:r>
-                      <a:endParaRPr lang="en-US" sz="1300" dirty="0">
+                      <a:endParaRPr lang="en-US" sz="1150" dirty="0">
+                        <a:latin typeface="Calibri" charset="0"/>
+                        <a:ea typeface="Calibri" charset="0"/>
+                        <a:cs typeface="Calibri" charset="0"/>
+                      </a:endParaRPr>
+                    </a:p>
+                  </a:txBody>
+                  <a:tcPr anchor="ctr">
+                    <a:lnL w="12700" cap="flat" cmpd="sng" algn="ctr">
+                      <a:solidFill>
+                        <a:srgbClr val="E2E7F2"/>
+                      </a:solidFill>
+                      <a:prstDash val="solid"/>
+                      <a:round/>
+                      <a:headEnd type="none" w="med" len="med"/>
+                      <a:tailEnd type="none" w="med" len="med"/>
+                    </a:lnL>
+                    <a:lnR w="12700" cap="flat" cmpd="sng" algn="ctr">
+                      <a:solidFill>
+                        <a:srgbClr val="E2E7F2"/>
+                      </a:solidFill>
+                      <a:prstDash val="solid"/>
+                      <a:round/>
+                      <a:headEnd type="none" w="med" len="med"/>
+                      <a:tailEnd type="none" w="med" len="med"/>
+                    </a:lnR>
+                    <a:lnT w="12700" cap="flat" cmpd="sng" algn="ctr">
+                      <a:solidFill>
+                        <a:srgbClr val="E2E7F2"/>
+                      </a:solidFill>
+                      <a:prstDash val="solid"/>
+                      <a:round/>
+                      <a:headEnd type="none" w="med" len="med"/>
+                      <a:tailEnd type="none" w="med" len="med"/>
+                    </a:lnT>
+                    <a:lnB w="12700" cap="flat" cmpd="sng" algn="ctr">
+                      <a:solidFill>
+                        <a:srgbClr val="E2E7F2"/>
+                      </a:solidFill>
+                      <a:prstDash val="solid"/>
+                      <a:round/>
+                      <a:headEnd type="none" w="med" len="med"/>
+                      <a:tailEnd type="none" w="med" len="med"/>
+                    </a:lnB>
+                    <a:solidFill>
+                      <a:srgbClr val="FFFFFF"/>
+                    </a:solidFill>
+                  </a:tcPr>
+                </a:tc>
+                <a:tc>
+                  <a:txBody>
+                    <a:bodyPr/>
+                    <a:lstStyle/>
+                    <a:p>
+                      <a:pPr marL="0" indent="0" algn="ctr">
+                        <a:buNone/>
+                      </a:pPr>
+                      <a:r>
+                        <a:rPr lang="en-US" sz="1150" dirty="0">
+                          <a:solidFill>
+                            <a:srgbClr val="141A45"/>
+                          </a:solidFill>
+                          <a:latin typeface="Calibri" pitchFamily="34" charset="0"/>
+                          <a:ea typeface="Calibri" pitchFamily="34" charset="-122"/>
+                          <a:cs typeface="Calibri" pitchFamily="34" charset="-120"/>
+                        </a:rPr>
+                        <a:t>32.6%</a:t>
+                      </a:r>
+                      <a:endParaRPr lang="en-US" sz="1150" dirty="0">
+                        <a:latin typeface="Calibri" charset="0"/>
+                        <a:ea typeface="Calibri" charset="0"/>
+                        <a:cs typeface="Calibri" charset="0"/>
+                      </a:endParaRPr>
+                    </a:p>
+                  </a:txBody>
+                  <a:tcPr anchor="ctr">
+                    <a:lnL w="12700" cap="flat" cmpd="sng" algn="ctr">
+                      <a:solidFill>
+                        <a:srgbClr val="E2E7F2"/>
+                      </a:solidFill>
+                      <a:prstDash val="solid"/>
+                      <a:round/>
+                      <a:headEnd type="none" w="med" len="med"/>
+                      <a:tailEnd type="none" w="med" len="med"/>
+                    </a:lnL>
+                    <a:lnR w="12700" cap="flat" cmpd="sng" algn="ctr">
+                      <a:solidFill>
+                        <a:srgbClr val="E2E7F2"/>
+                      </a:solidFill>
+                      <a:prstDash val="solid"/>
+                      <a:round/>
+                      <a:headEnd type="none" w="med" len="med"/>
+                      <a:tailEnd type="none" w="med" len="med"/>
+                    </a:lnR>
+                    <a:lnT w="12700" cap="flat" cmpd="sng" algn="ctr">
+                      <a:solidFill>
+                        <a:srgbClr val="E2E7F2"/>
+                      </a:solidFill>
+                      <a:prstDash val="solid"/>
+                      <a:round/>
+                      <a:headEnd type="none" w="med" len="med"/>
+                      <a:tailEnd type="none" w="med" len="med"/>
+                    </a:lnT>
+                    <a:lnB w="12700" cap="flat" cmpd="sng" algn="ctr">
+                      <a:solidFill>
+                        <a:srgbClr val="E2E7F2"/>
+                      </a:solidFill>
+                      <a:prstDash val="solid"/>
+                      <a:round/>
+                      <a:headEnd type="none" w="med" len="med"/>
+                      <a:tailEnd type="none" w="med" len="med"/>
+                    </a:lnB>
+                    <a:solidFill>
+                      <a:srgbClr val="FFFFFF"/>
+                    </a:solidFill>
+                  </a:tcPr>
+                </a:tc>
+                <a:tc>
+                  <a:txBody>
+                    <a:bodyPr/>
+                    <a:lstStyle/>
+                    <a:p>
+                      <a:pPr marL="0" indent="0" algn="ctr">
+                        <a:buNone/>
+                      </a:pPr>
+                      <a:r>
+                        <a:rPr lang="en-US" sz="1150" dirty="0">
+                          <a:solidFill>
+                            <a:srgbClr val="141A45"/>
+                          </a:solidFill>
+                          <a:latin typeface="Calibri" pitchFamily="34" charset="0"/>
+                          <a:ea typeface="Calibri" pitchFamily="34" charset="-122"/>
+                          <a:cs typeface="Calibri" pitchFamily="34" charset="-120"/>
+                        </a:rPr>
+                        <a:t>14.0%</a:t>
+                      </a:r>
+                      <a:endParaRPr lang="en-US" sz="1150" dirty="0">
+                        <a:latin typeface="Calibri" charset="0"/>
+                        <a:ea typeface="Calibri" charset="0"/>
+                        <a:cs typeface="Calibri" charset="0"/>
+                      </a:endParaRPr>
+                    </a:p>
+                  </a:txBody>
+                  <a:tcPr anchor="ctr">
+                    <a:lnL w="12700" cap="flat" cmpd="sng" algn="ctr">
+                      <a:solidFill>
+                        <a:srgbClr val="E2E7F2"/>
+                      </a:solidFill>
+                      <a:prstDash val="solid"/>
+                      <a:round/>
+                      <a:headEnd type="none" w="med" len="med"/>
+                      <a:tailEnd type="none" w="med" len="med"/>
+                    </a:lnL>
+                    <a:lnR w="12700" cap="flat" cmpd="sng" algn="ctr">
+                      <a:solidFill>
+                        <a:srgbClr val="E2E7F2"/>
+                      </a:solidFill>
+                      <a:prstDash val="solid"/>
+                      <a:round/>
+                      <a:headEnd type="none" w="med" len="med"/>
+                      <a:tailEnd type="none" w="med" len="med"/>
+                    </a:lnR>
+                    <a:lnT w="12700" cap="flat" cmpd="sng" algn="ctr">
+                      <a:solidFill>
+                        <a:srgbClr val="E2E7F2"/>
+                      </a:solidFill>
+                      <a:prstDash val="solid"/>
+                      <a:round/>
+                      <a:headEnd type="none" w="med" len="med"/>
+                      <a:tailEnd type="none" w="med" len="med"/>
+                    </a:lnT>
+                    <a:lnB w="12700" cap="flat" cmpd="sng" algn="ctr">
+                      <a:solidFill>
+                        <a:srgbClr val="E2E7F2"/>
+                      </a:solidFill>
+                      <a:prstDash val="solid"/>
+                      <a:round/>
+                      <a:headEnd type="none" w="med" len="med"/>
+                      <a:tailEnd type="none" w="med" len="med"/>
+                    </a:lnB>
+                    <a:solidFill>
+                      <a:srgbClr val="FFFFFF"/>
+                    </a:solidFill>
+                  </a:tcPr>
+                </a:tc>
+                <a:tc>
+                  <a:txBody>
+                    <a:bodyPr/>
+                    <a:lstStyle/>
+                    <a:p>
+                      <a:pPr marL="0" indent="0" algn="ctr">
+                        <a:buNone/>
+                      </a:pPr>
+                      <a:r>
+                        <a:rPr lang="en-US" sz="1150" dirty="0">
+                          <a:solidFill>
+                            <a:srgbClr val="141A45"/>
+                          </a:solidFill>
+                          <a:latin typeface="Calibri" pitchFamily="34" charset="0"/>
+                          <a:ea typeface="Calibri" pitchFamily="34" charset="-122"/>
+                          <a:cs typeface="Calibri" pitchFamily="34" charset="-120"/>
+                        </a:rPr>
+                        <a:t>4.7%</a:t>
+                      </a:r>
+                      <a:endParaRPr lang="en-US" sz="1150" dirty="0">
+                        <a:latin typeface="Calibri" charset="0"/>
+                        <a:ea typeface="Calibri" charset="0"/>
+                        <a:cs typeface="Calibri" charset="0"/>
+                      </a:endParaRPr>
+                    </a:p>
+                  </a:txBody>
+                  <a:tcPr anchor="ctr">
+                    <a:lnL w="12700" cap="flat" cmpd="sng" algn="ctr">
+                      <a:solidFill>
+                        <a:srgbClr val="E2E7F2"/>
+                      </a:solidFill>
+                      <a:prstDash val="solid"/>
+                      <a:round/>
+                      <a:headEnd type="none" w="med" len="med"/>
+                      <a:tailEnd type="none" w="med" len="med"/>
+                    </a:lnL>
+                    <a:lnR w="12700" cap="flat" cmpd="sng" algn="ctr">
+                      <a:solidFill>
+                        <a:srgbClr val="E2E7F2"/>
+                      </a:solidFill>
+                      <a:prstDash val="solid"/>
+                      <a:round/>
+                      <a:headEnd type="none" w="med" len="med"/>
+                      <a:tailEnd type="none" w="med" len="med"/>
+                    </a:lnR>
+                    <a:lnT w="12700" cap="flat" cmpd="sng" algn="ctr">
+                      <a:solidFill>
+                        <a:srgbClr val="E2E7F2"/>
+                      </a:solidFill>
+                      <a:prstDash val="solid"/>
+                      <a:round/>
+                      <a:headEnd type="none" w="med" len="med"/>
+                      <a:tailEnd type="none" w="med" len="med"/>
+                    </a:lnT>
+                    <a:lnB w="12700" cap="flat" cmpd="sng" algn="ctr">
+                      <a:solidFill>
+                        <a:srgbClr val="E2E7F2"/>
+                      </a:solidFill>
+                      <a:prstDash val="solid"/>
+                      <a:round/>
+                      <a:headEnd type="none" w="med" len="med"/>
+                      <a:tailEnd type="none" w="med" len="med"/>
+                    </a:lnB>
+                    <a:solidFill>
+                      <a:srgbClr val="FFFFFF"/>
+                    </a:solidFill>
+                  </a:tcPr>
+                </a:tc>
+                <a:tc>
+                  <a:txBody>
+                    <a:bodyPr/>
+                    <a:lstStyle/>
+                    <a:p>
+                      <a:pPr marL="0" indent="0" algn="ctr">
+                        <a:buNone/>
+                      </a:pPr>
+                      <a:r>
+                        <a:rPr lang="en-US" sz="1150" dirty="0">
+                          <a:solidFill>
+                            <a:srgbClr val="141A45"/>
+                          </a:solidFill>
+                          <a:latin typeface="Calibri" pitchFamily="34" charset="0"/>
+                          <a:ea typeface="Calibri" pitchFamily="34" charset="-122"/>
+                          <a:cs typeface="Calibri" pitchFamily="34" charset="-120"/>
+                        </a:rPr>
+                        <a:t>S/13.3M</a:t>
+                      </a:r>
+                      <a:endParaRPr lang="en-US" sz="1150" dirty="0">
+                        <a:latin typeface="Calibri" charset="0"/>
+                        <a:ea typeface="Calibri" charset="0"/>
+                        <a:cs typeface="Calibri" charset="0"/>
+                      </a:endParaRPr>
+                    </a:p>
+                  </a:txBody>
+                  <a:tcPr anchor="ctr">
+                    <a:lnL w="12700" cap="flat" cmpd="sng" algn="ctr">
+                      <a:solidFill>
+                        <a:srgbClr val="E2E7F2"/>
+                      </a:solidFill>
+                      <a:prstDash val="solid"/>
+                      <a:round/>
+                      <a:headEnd type="none" w="med" len="med"/>
+                      <a:tailEnd type="none" w="med" len="med"/>
+                    </a:lnL>
+                    <a:lnR w="12700" cap="flat" cmpd="sng" algn="ctr">
+                      <a:solidFill>
+                        <a:srgbClr val="E2E7F2"/>
+                      </a:solidFill>
+                      <a:prstDash val="solid"/>
+                      <a:round/>
+                      <a:headEnd type="none" w="med" len="med"/>
+                      <a:tailEnd type="none" w="med" len="med"/>
+                    </a:lnR>
+                    <a:lnT w="12700" cap="flat" cmpd="sng" algn="ctr">
+                      <a:solidFill>
+                        <a:srgbClr val="E2E7F2"/>
+                      </a:solidFill>
+                      <a:prstDash val="solid"/>
+                      <a:round/>
+                      <a:headEnd type="none" w="med" len="med"/>
+                      <a:tailEnd type="none" w="med" len="med"/>
+                    </a:lnT>
+                    <a:lnB w="12700" cap="flat" cmpd="sng" algn="ctr">
+                      <a:solidFill>
+                        <a:srgbClr val="E2E7F2"/>
+                      </a:solidFill>
+                      <a:prstDash val="solid"/>
+                      <a:round/>
+                      <a:headEnd type="none" w="med" len="med"/>
+                      <a:tailEnd type="none" w="med" len="med"/>
+                    </a:lnB>
+                    <a:solidFill>
+                      <a:srgbClr val="FFFFFF"/>
+                    </a:solidFill>
+                  </a:tcPr>
+                </a:tc>
+              </a:tr>
+              <a:tr h="438912">
+                <a:tc>
+                  <a:txBody>
+                    <a:bodyPr/>
+                    <a:lstStyle/>
+                    <a:p>
+                      <a:pPr marL="0" indent="0" algn="l">
+                        <a:buNone/>
+                      </a:pPr>
+                      <a:r>
+                        <a:rPr lang="en-US" sz="1150" b="1" dirty="0">
+                          <a:solidFill>
+                            <a:srgbClr val="141A45"/>
+                          </a:solidFill>
+                          <a:latin typeface="Calibri" pitchFamily="34" charset="0"/>
+                          <a:ea typeface="Calibri" pitchFamily="34" charset="-122"/>
+                          <a:cs typeface="Calibri" pitchFamily="34" charset="-120"/>
+                        </a:rPr>
+                        <a:t>Medio Riesgo</a:t>
+                      </a:r>
+                      <a:endParaRPr lang="en-US" sz="1150" dirty="0">
                         <a:latin typeface="Calibri" charset="0"/>
                         <a:ea typeface="Calibri" charset="0"/>
                         <a:cs typeface="Calibri" charset="0"/>
@@ -11544,7 +12099,7 @@
                         <a:buNone/>
                       </a:pPr>
                       <a:r>
-                        <a:rPr lang="en-US" sz="1300" dirty="0">
+                        <a:rPr lang="en-US" sz="1150" dirty="0">
                           <a:solidFill>
                             <a:srgbClr val="141A45"/>
                           </a:solidFill>
@@ -11552,9 +12107,9 @@
                           <a:ea typeface="Calibri" pitchFamily="34" charset="-122"/>
                           <a:cs typeface="Calibri" pitchFamily="34" charset="-120"/>
                         </a:rPr>
-                        <a:t>660</a:t>
+                        <a:t>30.1%</a:t>
                       </a:r>
-                      <a:endParaRPr lang="en-US" sz="1300" dirty="0">
+                      <a:endParaRPr lang="en-US" sz="1150" dirty="0">
                         <a:latin typeface="Calibri" charset="0"/>
                         <a:ea typeface="Calibri" charset="0"/>
                         <a:cs typeface="Calibri" charset="0"/>
@@ -11612,7 +12167,7 @@
                         <a:buNone/>
                       </a:pPr>
                       <a:r>
-                        <a:rPr lang="en-US" sz="1300" dirty="0">
+                        <a:rPr lang="en-US" sz="1150" dirty="0">
                           <a:solidFill>
                             <a:srgbClr val="141A45"/>
                           </a:solidFill>
@@ -11620,9 +12175,9 @@
                           <a:ea typeface="Calibri" pitchFamily="34" charset="-122"/>
                           <a:cs typeface="Calibri" pitchFamily="34" charset="-120"/>
                         </a:rPr>
-                        <a:t>72%</a:t>
+                        <a:t>18.0%</a:t>
                       </a:r>
-                      <a:endParaRPr lang="en-US" sz="1300" dirty="0">
+                      <a:endParaRPr lang="en-US" sz="1150" dirty="0">
                         <a:latin typeface="Calibri" charset="0"/>
                         <a:ea typeface="Calibri" charset="0"/>
                         <a:cs typeface="Calibri" charset="0"/>
@@ -11680,7 +12235,7 @@
                         <a:buNone/>
                       </a:pPr>
                       <a:r>
-                        <a:rPr lang="en-US" sz="1300" dirty="0">
+                        <a:rPr lang="en-US" sz="1150" dirty="0">
                           <a:solidFill>
                             <a:srgbClr val="141A45"/>
                           </a:solidFill>
@@ -11688,9 +12243,9 @@
                           <a:ea typeface="Calibri" pitchFamily="34" charset="-122"/>
                           <a:cs typeface="Calibri" pitchFamily="34" charset="-120"/>
                         </a:rPr>
-                        <a:t>2.1%</a:t>
+                        <a:t>7.4%</a:t>
                       </a:r>
-                      <a:endParaRPr lang="en-US" sz="1300" dirty="0">
+                      <a:endParaRPr lang="en-US" sz="1150" dirty="0">
                         <a:latin typeface="Calibri" charset="0"/>
                         <a:ea typeface="Calibri" charset="0"/>
                         <a:cs typeface="Calibri" charset="0"/>
@@ -11748,7 +12303,7 @@
                         <a:buNone/>
                       </a:pPr>
                       <a:r>
-                        <a:rPr lang="en-US" sz="1300" dirty="0">
+                        <a:rPr lang="en-US" sz="1150" dirty="0">
                           <a:solidFill>
                             <a:srgbClr val="141A45"/>
                           </a:solidFill>
@@ -11756,9 +12311,9 @@
                           <a:ea typeface="Calibri" pitchFamily="34" charset="-122"/>
                           <a:cs typeface="Calibri" pitchFamily="34" charset="-120"/>
                         </a:rPr>
-                        <a:t>2.05%</a:t>
+                        <a:t>S/19.3M</a:t>
                       </a:r>
-                      <a:endParaRPr lang="en-US" sz="1300" dirty="0">
+                      <a:endParaRPr lang="en-US" sz="1150" dirty="0">
                         <a:latin typeface="Calibri" charset="0"/>
                         <a:ea typeface="Calibri" charset="0"/>
                         <a:cs typeface="Calibri" charset="0"/>
@@ -11807,13 +12362,8 @@
                     </a:solidFill>
                   </a:tcPr>
                 </a:tc>
-                <a:extLst>
-                  <a:ext uri="{0D108BD9-81ED-4DB2-BD59-A6C34878D82A}">
-                    <a16:rowId xmlns:a16="http://schemas.microsoft.com/office/drawing/2014/main" val="10001"/>
-                  </a:ext>
-                </a:extLst>
               </a:tr>
-              <a:tr h="548640">
+              <a:tr h="438912">
                 <a:tc>
                   <a:txBody>
                     <a:bodyPr/>
@@ -11823,7 +12373,7 @@
                         <a:buNone/>
                       </a:pPr>
                       <a:r>
-                        <a:rPr lang="en-US" sz="1300" b="1" dirty="0">
+                        <a:rPr lang="en-US" sz="1150" b="1" dirty="0">
                           <a:solidFill>
                             <a:srgbClr val="141A45"/>
                           </a:solidFill>
@@ -11831,9 +12381,9 @@
                           <a:ea typeface="Calibri" pitchFamily="34" charset="-122"/>
                           <a:cs typeface="Calibri" pitchFamily="34" charset="-120"/>
                         </a:rPr>
-                        <a:t>Recomendado</a:t>
+                        <a:t>Alto Riesgo</a:t>
                       </a:r>
-                      <a:endParaRPr lang="en-US" sz="1300" dirty="0">
+                      <a:endParaRPr lang="en-US" sz="1150" dirty="0">
                         <a:latin typeface="Calibri" charset="0"/>
                         <a:ea typeface="Calibri" charset="0"/>
                         <a:cs typeface="Calibri" charset="0"/>
@@ -11878,7 +12428,7 @@
                       <a:tailEnd type="none" w="med" len="med"/>
                     </a:lnB>
                     <a:solidFill>
-                      <a:srgbClr val="EAF1FF"/>
+                      <a:srgbClr val="FFFFFF"/>
                     </a:solidFill>
                   </a:tcPr>
                 </a:tc>
@@ -11891,17 +12441,17 @@
                         <a:buNone/>
                       </a:pPr>
                       <a:r>
-                        <a:rPr lang="en-US" sz="1300" b="1" dirty="0">
+                        <a:rPr lang="en-US" sz="1150" dirty="0">
                           <a:solidFill>
-                            <a:srgbClr val="1E2761"/>
+                            <a:srgbClr val="141A45"/>
                           </a:solidFill>
                           <a:latin typeface="Calibri" pitchFamily="34" charset="0"/>
                           <a:ea typeface="Calibri" pitchFamily="34" charset="-122"/>
                           <a:cs typeface="Calibri" pitchFamily="34" charset="-120"/>
                         </a:rPr>
-                        <a:t>635</a:t>
+                        <a:t>28.9%</a:t>
                       </a:r>
-                      <a:endParaRPr lang="en-US" sz="1300" dirty="0">
+                      <a:endParaRPr lang="en-US" sz="1150" dirty="0">
                         <a:latin typeface="Calibri" charset="0"/>
                         <a:ea typeface="Calibri" charset="0"/>
                         <a:cs typeface="Calibri" charset="0"/>
@@ -11946,7 +12496,7 @@
                       <a:tailEnd type="none" w="med" len="med"/>
                     </a:lnB>
                     <a:solidFill>
-                      <a:srgbClr val="EAF1FF"/>
+                      <a:srgbClr val="FFFFFF"/>
                     </a:solidFill>
                   </a:tcPr>
                 </a:tc>
@@ -11959,17 +12509,17 @@
                         <a:buNone/>
                       </a:pPr>
                       <a:r>
-                        <a:rPr lang="en-US" sz="1300" b="1" dirty="0">
+                        <a:rPr lang="en-US" sz="1150" dirty="0">
                           <a:solidFill>
-                            <a:srgbClr val="1E2761"/>
+                            <a:srgbClr val="141A45"/>
                           </a:solidFill>
                           <a:latin typeface="Calibri" pitchFamily="34" charset="0"/>
                           <a:ea typeface="Calibri" pitchFamily="34" charset="-122"/>
                           <a:cs typeface="Calibri" pitchFamily="34" charset="-120"/>
                         </a:rPr>
-                        <a:t>81%</a:t>
+                        <a:t>28.0%</a:t>
                       </a:r>
-                      <a:endParaRPr lang="en-US" sz="1300" dirty="0">
+                      <a:endParaRPr lang="en-US" sz="1150" dirty="0">
                         <a:latin typeface="Calibri" charset="0"/>
                         <a:ea typeface="Calibri" charset="0"/>
                         <a:cs typeface="Calibri" charset="0"/>
@@ -12014,7 +12564,7 @@
                       <a:tailEnd type="none" w="med" len="med"/>
                     </a:lnB>
                     <a:solidFill>
-                      <a:srgbClr val="EAF1FF"/>
+                      <a:srgbClr val="FFFFFF"/>
                     </a:solidFill>
                   </a:tcPr>
                 </a:tc>
@@ -12027,17 +12577,17 @@
                         <a:buNone/>
                       </a:pPr>
                       <a:r>
-                        <a:rPr lang="en-US" sz="1300" b="1" dirty="0">
+                        <a:rPr lang="en-US" sz="1150" dirty="0">
                           <a:solidFill>
-                            <a:srgbClr val="1E2761"/>
+                            <a:srgbClr val="141A45"/>
                           </a:solidFill>
                           <a:latin typeface="Calibri" pitchFamily="34" charset="0"/>
                           <a:ea typeface="Calibri" pitchFamily="34" charset="-122"/>
                           <a:cs typeface="Calibri" pitchFamily="34" charset="-120"/>
                         </a:rPr>
-                        <a:t>3.0%</a:t>
+                        <a:t>12.9%</a:t>
                       </a:r>
-                      <a:endParaRPr lang="en-US" sz="1300" dirty="0">
+                      <a:endParaRPr lang="en-US" sz="1150" dirty="0">
                         <a:latin typeface="Calibri" charset="0"/>
                         <a:ea typeface="Calibri" charset="0"/>
                         <a:cs typeface="Calibri" charset="0"/>
@@ -12082,7 +12632,7 @@
                       <a:tailEnd type="none" w="med" len="med"/>
                     </a:lnB>
                     <a:solidFill>
-                      <a:srgbClr val="EAF1FF"/>
+                      <a:srgbClr val="FFFFFF"/>
                     </a:solidFill>
                   </a:tcPr>
                 </a:tc>
@@ -12095,17 +12645,17 @@
                         <a:buNone/>
                       </a:pPr>
                       <a:r>
-                        <a:rPr lang="en-US" sz="1300" b="1" dirty="0">
+                        <a:rPr lang="en-US" sz="1150" dirty="0">
                           <a:solidFill>
-                            <a:srgbClr val="1E2761"/>
+                            <a:srgbClr val="141A45"/>
                           </a:solidFill>
                           <a:latin typeface="Calibri" pitchFamily="34" charset="0"/>
                           <a:ea typeface="Calibri" pitchFamily="34" charset="-122"/>
                           <a:cs typeface="Calibri" pitchFamily="34" charset="-120"/>
                         </a:rPr>
-                        <a:t>2.20%</a:t>
+                        <a:t>S/32.5M</a:t>
                       </a:r>
-                      <a:endParaRPr lang="en-US" sz="1300" dirty="0">
+                      <a:endParaRPr lang="en-US" sz="1150" dirty="0">
                         <a:latin typeface="Calibri" charset="0"/>
                         <a:ea typeface="Calibri" charset="0"/>
                         <a:cs typeface="Calibri" charset="0"/>
@@ -12150,17 +12700,12 @@
                       <a:tailEnd type="none" w="med" len="med"/>
                     </a:lnB>
                     <a:solidFill>
-                      <a:srgbClr val="EAF1FF"/>
+                      <a:srgbClr val="FFFFFF"/>
                     </a:solidFill>
                   </a:tcPr>
                 </a:tc>
-                <a:extLst>
-                  <a:ext uri="{0D108BD9-81ED-4DB2-BD59-A6C34878D82A}">
-                    <a16:rowId xmlns:a16="http://schemas.microsoft.com/office/drawing/2014/main" val="10002"/>
-                  </a:ext>
-                </a:extLst>
               </a:tr>
-              <a:tr h="548640">
+              <a:tr h="438912">
                 <a:tc>
                   <a:txBody>
                     <a:bodyPr/>
@@ -12170,7 +12715,7 @@
                         <a:buNone/>
                       </a:pPr>
                       <a:r>
-                        <a:rPr lang="en-US" sz="1300" b="1" dirty="0">
+                        <a:rPr lang="en-US" sz="1150" b="1" dirty="0">
                           <a:solidFill>
                             <a:srgbClr val="141A45"/>
                           </a:solidFill>
@@ -12178,9 +12723,9 @@
                           <a:ea typeface="Calibri" pitchFamily="34" charset="-122"/>
                           <a:cs typeface="Calibri" pitchFamily="34" charset="-120"/>
                         </a:rPr>
-                        <a:t>Agresivo</a:t>
+                        <a:t>Muy Alto Riesgo</a:t>
                       </a:r>
-                      <a:endParaRPr lang="en-US" sz="1300" dirty="0">
+                      <a:endParaRPr lang="en-US" sz="1150" dirty="0">
                         <a:latin typeface="Calibri" charset="0"/>
                         <a:ea typeface="Calibri" charset="0"/>
                         <a:cs typeface="Calibri" charset="0"/>
@@ -12238,7 +12783,7 @@
                         <a:buNone/>
                       </a:pPr>
                       <a:r>
-                        <a:rPr lang="en-US" sz="1300" dirty="0">
+                        <a:rPr lang="en-US" sz="1150" dirty="0">
                           <a:solidFill>
                             <a:srgbClr val="141A45"/>
                           </a:solidFill>
@@ -12246,9 +12791,9 @@
                           <a:ea typeface="Calibri" pitchFamily="34" charset="-122"/>
                           <a:cs typeface="Calibri" pitchFamily="34" charset="-120"/>
                         </a:rPr>
-                        <a:t>610</a:t>
+                        <a:t>8.4%</a:t>
                       </a:r>
-                      <a:endParaRPr lang="en-US" sz="1300" dirty="0">
+                      <a:endParaRPr lang="en-US" sz="1150" dirty="0">
                         <a:latin typeface="Calibri" charset="0"/>
                         <a:ea typeface="Calibri" charset="0"/>
                         <a:cs typeface="Calibri" charset="0"/>
@@ -12306,7 +12851,7 @@
                         <a:buNone/>
                       </a:pPr>
                       <a:r>
-                        <a:rPr lang="en-US" sz="1300" dirty="0">
+                        <a:rPr lang="en-US" sz="1150" dirty="0">
                           <a:solidFill>
                             <a:srgbClr val="141A45"/>
                           </a:solidFill>
@@ -12314,9 +12859,9 @@
                           <a:ea typeface="Calibri" pitchFamily="34" charset="-122"/>
                           <a:cs typeface="Calibri" pitchFamily="34" charset="-120"/>
                         </a:rPr>
-                        <a:t>89%</a:t>
+                        <a:t>35.0%</a:t>
                       </a:r>
-                      <a:endParaRPr lang="en-US" sz="1300" dirty="0">
+                      <a:endParaRPr lang="en-US" sz="1150" dirty="0">
                         <a:latin typeface="Calibri" charset="0"/>
                         <a:ea typeface="Calibri" charset="0"/>
                         <a:cs typeface="Calibri" charset="0"/>
@@ -12374,7 +12919,7 @@
                         <a:buNone/>
                       </a:pPr>
                       <a:r>
-                        <a:rPr lang="en-US" sz="1300" dirty="0">
+                        <a:rPr lang="en-US" sz="1150" dirty="0">
                           <a:solidFill>
                             <a:srgbClr val="141A45"/>
                           </a:solidFill>
@@ -12382,9 +12927,9 @@
                           <a:ea typeface="Calibri" pitchFamily="34" charset="-122"/>
                           <a:cs typeface="Calibri" pitchFamily="34" charset="-120"/>
                         </a:rPr>
-                        <a:t>4.6%</a:t>
+                        <a:t>-3.9%</a:t>
                       </a:r>
-                      <a:endParaRPr lang="en-US" sz="1300" dirty="0">
+                      <a:endParaRPr lang="en-US" sz="1150" dirty="0">
                         <a:latin typeface="Calibri" charset="0"/>
                         <a:ea typeface="Calibri" charset="0"/>
                         <a:cs typeface="Calibri" charset="0"/>
@@ -12442,7 +12987,7 @@
                         <a:buNone/>
                       </a:pPr>
                       <a:r>
-                        <a:rPr lang="en-US" sz="1300" dirty="0">
+                        <a:rPr lang="en-US" sz="1150" dirty="0">
                           <a:solidFill>
                             <a:srgbClr val="141A45"/>
                           </a:solidFill>
@@ -12450,9 +12995,9 @@
                           <a:ea typeface="Calibri" pitchFamily="34" charset="-122"/>
                           <a:cs typeface="Calibri" pitchFamily="34" charset="-120"/>
                         </a:rPr>
-                        <a:t>2.02%</a:t>
+                        <a:t>S/-2.8M</a:t>
                       </a:r>
-                      <a:endParaRPr lang="en-US" sz="1300" dirty="0">
+                      <a:endParaRPr lang="en-US" sz="1150" dirty="0">
                         <a:latin typeface="Calibri" charset="0"/>
                         <a:ea typeface="Calibri" charset="0"/>
                         <a:cs typeface="Calibri" charset="0"/>
@@ -12501,11 +13046,6 @@
                     </a:solidFill>
                   </a:tcPr>
                 </a:tc>
-                <a:extLst>
-                  <a:ext uri="{0D108BD9-81ED-4DB2-BD59-A6C34878D82A}">
-                    <a16:rowId xmlns:a16="http://schemas.microsoft.com/office/drawing/2014/main" val="10003"/>
-                  </a:ext>
-                </a:extLst>
               </a:tr>
             </a:tbl>
           </a:graphicData>
@@ -12683,7 +13223,7 @@
                 <a:ea typeface="Calibri" pitchFamily="34" charset="-122"/>
                 <a:cs typeface="Calibri" pitchFamily="34" charset="-120"/>
               </a:rPr>
-              <a:t>El escenario 'Recomendado' (cutoff 635) maximiza el ROA de cartera: un cutoff más agresivo aprueba más volumen pero la mora adicional erosiona la rentabilidad marginal.</a:t>
+              <a:t>El foco de gestión debe estar en Muy Alto Riesgo (8.4% de la cartera, ROA -3.9%) — candidata a rechazo o repricing. Las otras 3 bandas ya son rentables (ROA 4.7% a 12.9%) y no requieren intervención.</a:t>
             </a:r>
             <a:endParaRPr lang="en-US" sz="1250" dirty="0"/>
           </a:p>
@@ -13018,7 +13558,7 @@
                 <a:ea typeface="Cambria" pitchFamily="34" charset="-122"/>
                 <a:cs typeface="Cambria" pitchFamily="34" charset="-120"/>
               </a:rPr>
-              <a:t>Cutoff operativo</a:t>
+              <a:t>Política de 4 bandas</a:t>
             </a:r>
             <a:endParaRPr lang="en-US" sz="1500" dirty="0"/>
           </a:p>
@@ -13057,7 +13597,7 @@
                 <a:ea typeface="Calibri" pitchFamily="34" charset="-122"/>
                 <a:cs typeface="Calibri" pitchFamily="34" charset="-120"/>
               </a:rPr>
-              <a:t>Adoptar el escenario recomendado (score 635) como política inicial, con revisión a 90 días.</a:t>
+              <a:t>Adoptar las 4 bandas de riesgo ya calibradas en producción, con foco de revisión a 90 días en el tratamiento de Muy Alto Riesgo (única banda no rentable).</a:t>
             </a:r>
             <a:endParaRPr lang="en-US" sz="1200" dirty="0"/>
           </a:p>
@@ -14042,7 +14582,7 @@
                 <a:ea typeface="Calibri" pitchFamily="34" charset="-122"/>
                 <a:cs typeface="Calibri" pitchFamily="34" charset="-120"/>
               </a:rPr>
-              <a:t>Con el cutoff recomendado, el ROA de cartera mejora en +0.35 p.p. y la pérdida esperada cae 18% frente a la política vigente.</a:t>
+              <a:t>Con las 4 bandas de riesgo calibradas, el ROA de cartera ponderado es 7.18% y el 91.6% de la cartera está en bandas rentables — Muy Alto Riesgo (8.4%, ROA -3.9%) es el único segmento candidato a rechazo o repricing.</a:t>
             </a:r>
             <a:endParaRPr lang="en-US" sz="1400" dirty="0"/>
           </a:p>
@@ -19665,7 +20205,6 @@
             <a:pPr marL="0" indent="0">
               <a:buNone/>
             </a:pPr>
-            <a:endParaRPr lang="en-US" sz="1250" dirty="0"/>
             <a:r>
               <a:rPr lang="en-US" sz="1250" i="1" dirty="0">
                 <a:solidFill>
@@ -19677,6 +20216,7 @@
               </a:rPr>
               <a:t>Comparación de AUC (cross-validation) entre los 6 algoritmos evaluados en 03_training_model.ipynb.</a:t>
             </a:r>
+            <a:endParaRPr lang="en-US" sz="1250" dirty="0"/>
           </a:p>
         </p:txBody>
       </p:sp>
@@ -19839,7 +20379,6 @@
             <a:pPr marL="0" indent="0">
               <a:buNone/>
             </a:pPr>
-            <a:endParaRPr lang="en-US" sz="1500" dirty="0"/>
             <a:r>
               <a:rPr lang="en-US" sz="1500" b="1" dirty="0">
                 <a:solidFill>
@@ -19851,6 +20390,7 @@
               </a:rPr>
               <a:t>Por qué CatBoost</a:t>
             </a:r>
+            <a:endParaRPr lang="en-US" sz="1500" dirty="0"/>
           </a:p>
         </p:txBody>
       </p:sp>
@@ -19905,7 +20445,6 @@
             <a:pPr marL="0" indent="0">
               <a:buNone/>
             </a:pPr>
-            <a:endParaRPr lang="en-US" sz="1150" dirty="0"/>
             <a:r>
               <a:rPr lang="en-US" sz="1150" dirty="0">
                 <a:solidFill>
@@ -19917,6 +20456,7 @@
               </a:rPr>
               <a:t>LogisticRegression alcanzó un AUC (CV) de 0.825 — competitivo e interpretable, pero no fue el modelo elegido.</a:t>
             </a:r>
+            <a:endParaRPr lang="en-US" sz="1150" dirty="0"/>
           </a:p>
         </p:txBody>
       </p:sp>
@@ -19971,7 +20511,6 @@
             <a:pPr marL="0" indent="0">
               <a:buNone/>
             </a:pPr>
-            <a:endParaRPr lang="en-US" sz="1150" dirty="0"/>
             <a:r>
               <a:rPr lang="en-US" sz="1150" dirty="0">
                 <a:solidFill>
@@ -19983,6 +20522,7 @@
               </a:rPr>
               <a:t>CatBoost (0.864) y LightGBM (0.865) tuvieron mejor poder predictivo en la comparación de 6 modelos evaluados.</a:t>
             </a:r>
+            <a:endParaRPr lang="en-US" sz="1150" dirty="0"/>
           </a:p>
         </p:txBody>
       </p:sp>
@@ -20037,7 +20577,6 @@
             <a:pPr marL="0" indent="0">
               <a:buNone/>
             </a:pPr>
-            <a:endParaRPr lang="en-US" sz="1150" dirty="0"/>
             <a:r>
               <a:rPr lang="en-US" sz="1150" dirty="0">
                 <a:solidFill>
@@ -20049,6 +20588,7 @@
               </a:rPr>
               <a:t>CatBoost se seleccionó como campeón de producción por su balance entre desempeño e interpretabilidad (soporte nativo de SHAP).</a:t>
             </a:r>
+            <a:endParaRPr lang="en-US" sz="1150" dirty="0"/>
           </a:p>
         </p:txBody>
       </p:sp>
@@ -21237,7 +21777,6 @@
             <a:pPr marL="0" indent="0">
               <a:buNone/>
             </a:pPr>
-            <a:endParaRPr lang="en-US" sz="1700" dirty="0"/>
             <a:r>
               <a:rPr lang="en-US" sz="1700" b="1" dirty="0">
                 <a:solidFill>
@@ -21249,6 +21788,7 @@
               </a:rPr>
               <a:t>Bajo Riesgo</a:t>
             </a:r>
+            <a:endParaRPr lang="en-US" sz="1700" dirty="0"/>
           </a:p>
         </p:txBody>
       </p:sp>
@@ -21276,7 +21816,6 @@
             <a:pPr marL="0" indent="0">
               <a:buNone/>
             </a:pPr>
-            <a:endParaRPr lang="en-US" sz="1300" dirty="0"/>
             <a:r>
               <a:rPr lang="en-US" sz="1300" dirty="0">
                 <a:solidFill>
@@ -21288,6 +21827,7 @@
               </a:rPr>
               <a:t>Cliente real (set de validación)</a:t>
             </a:r>
+            <a:endParaRPr lang="en-US" sz="1300" dirty="0"/>
           </a:p>
         </p:txBody>
       </p:sp>
@@ -21315,7 +21855,6 @@
             <a:pPr marL="0" indent="0">
               <a:buNone/>
             </a:pPr>
-            <a:endParaRPr lang="en-US" sz="2200" dirty="0"/>
             <a:r>
               <a:rPr lang="en-US" sz="2200" b="1" dirty="0">
                 <a:solidFill>
@@ -21327,6 +21866,7 @@
               </a:rPr>
               <a:t>PD: 0.60%</a:t>
             </a:r>
+            <a:endParaRPr lang="en-US" sz="2200" dirty="0"/>
           </a:p>
         </p:txBody>
       </p:sp>
@@ -21491,7 +22031,6 @@
             <a:pPr marL="0" indent="0">
               <a:buNone/>
             </a:pPr>
-            <a:endParaRPr lang="en-US" sz="1700" dirty="0"/>
             <a:r>
               <a:rPr lang="en-US" sz="1700" b="1" dirty="0">
                 <a:solidFill>
@@ -21503,6 +22042,7 @@
               </a:rPr>
               <a:t>Medio Riesgo</a:t>
             </a:r>
+            <a:endParaRPr lang="en-US" sz="1700" dirty="0"/>
           </a:p>
         </p:txBody>
       </p:sp>
@@ -21530,7 +22070,6 @@
             <a:pPr marL="0" indent="0">
               <a:buNone/>
             </a:pPr>
-            <a:endParaRPr lang="en-US" sz="1300" dirty="0"/>
             <a:r>
               <a:rPr lang="en-US" sz="1300" dirty="0">
                 <a:solidFill>
@@ -21542,6 +22081,7 @@
               </a:rPr>
               <a:t>Cliente real (set de validación)</a:t>
             </a:r>
+            <a:endParaRPr lang="en-US" sz="1300" dirty="0"/>
           </a:p>
         </p:txBody>
       </p:sp>
@@ -21569,7 +22109,6 @@
             <a:pPr marL="0" indent="0">
               <a:buNone/>
             </a:pPr>
-            <a:endParaRPr lang="en-US" sz="2200" dirty="0"/>
             <a:r>
               <a:rPr lang="en-US" sz="2200" b="1" dirty="0">
                 <a:solidFill>
@@ -21581,6 +22120,7 @@
               </a:rPr>
               <a:t>PD: 2.00%</a:t>
             </a:r>
+            <a:endParaRPr lang="en-US" sz="2200" dirty="0"/>
           </a:p>
         </p:txBody>
       </p:sp>
@@ -21745,7 +22285,6 @@
             <a:pPr marL="0" indent="0">
               <a:buNone/>
             </a:pPr>
-            <a:endParaRPr lang="en-US" sz="1700" dirty="0"/>
             <a:r>
               <a:rPr lang="en-US" sz="1700" b="1" dirty="0">
                 <a:solidFill>
@@ -21757,6 +22296,7 @@
               </a:rPr>
               <a:t>Alto Riesgo</a:t>
             </a:r>
+            <a:endParaRPr lang="en-US" sz="1700" dirty="0"/>
           </a:p>
         </p:txBody>
       </p:sp>
@@ -21784,7 +22324,6 @@
             <a:pPr marL="0" indent="0">
               <a:buNone/>
             </a:pPr>
-            <a:endParaRPr lang="en-US" sz="1300" dirty="0"/>
             <a:r>
               <a:rPr lang="en-US" sz="1300" dirty="0">
                 <a:solidFill>
@@ -21796,6 +22335,7 @@
               </a:rPr>
               <a:t>Cliente real (set de validación)</a:t>
             </a:r>
+            <a:endParaRPr lang="en-US" sz="1300" dirty="0"/>
           </a:p>
         </p:txBody>
       </p:sp>
@@ -21823,7 +22363,6 @@
             <a:pPr marL="0" indent="0">
               <a:buNone/>
             </a:pPr>
-            <a:endParaRPr lang="en-US" sz="2200" dirty="0"/>
             <a:r>
               <a:rPr lang="en-US" sz="2200" b="1" dirty="0">
                 <a:solidFill>
@@ -21835,6 +22374,7 @@
               </a:rPr>
               <a:t>PD: 8.00%</a:t>
             </a:r>
+            <a:endParaRPr lang="en-US" sz="2200" dirty="0"/>
           </a:p>
         </p:txBody>
       </p:sp>

</xml_diff>

<commit_message>
(fix) actualizacion del readme agregando interpretabilidad
</commit_message>
<xml_diff>
--- a/presentacion/Resumen_Presentacion.pptx
+++ b/presentacion/Resumen_Presentacion.pptx
@@ -20242,7 +20242,7 @@
         </p:nvSpPr>
         <p:spPr>
           <a:xfrm>
-            <a:off x="7680960" y="3080627"/>
+            <a:off x="7680960" y="3179242"/>
             <a:ext cx="82296" cy="82296"/>
           </a:xfrm>
           <a:prstGeom prst="ellipse">
@@ -20308,7 +20308,7 @@
         </p:nvSpPr>
         <p:spPr>
           <a:xfrm>
-            <a:off x="7680960" y="3949307"/>
+            <a:off x="7680960" y="4047922"/>
             <a:ext cx="82296" cy="82296"/>
           </a:xfrm>
           <a:prstGeom prst="ellipse">
@@ -20374,7 +20374,7 @@
         </p:nvSpPr>
         <p:spPr>
           <a:xfrm>
-            <a:off x="7680960" y="4817987"/>
+            <a:off x="7680960" y="4916602"/>
             <a:ext cx="82296" cy="82296"/>
           </a:xfrm>
           <a:prstGeom prst="ellipse">
@@ -20426,7 +20426,117 @@
                 <a:ea typeface="Calibri" pitchFamily="34" charset="-122"/>
                 <a:cs typeface="Calibri" pitchFamily="34" charset="-120"/>
               </a:rPr>
-              <a:t>El efecto de la edad es no lineal: clientes jóvenes concentran mayor riesgo relativo.</a:t>
+              <a:t>Con respect a la </a:t>
+            </a:r>
+            <a:r>
+              <a:rPr lang="en-US" sz="1150" dirty="0" err="1">
+                <a:solidFill>
+                  <a:srgbClr val="CADCFC"/>
+                </a:solidFill>
+                <a:latin typeface="Calibri" pitchFamily="34" charset="0"/>
+                <a:ea typeface="Calibri" pitchFamily="34" charset="-122"/>
+                <a:cs typeface="Calibri" pitchFamily="34" charset="-120"/>
+              </a:rPr>
+              <a:t>edad</a:t>
+            </a:r>
+            <a:r>
+              <a:rPr lang="en-US" sz="1150" dirty="0">
+                <a:solidFill>
+                  <a:srgbClr val="CADCFC"/>
+                </a:solidFill>
+                <a:latin typeface="Calibri" pitchFamily="34" charset="0"/>
+                <a:ea typeface="Calibri" pitchFamily="34" charset="-122"/>
+                <a:cs typeface="Calibri" pitchFamily="34" charset="-120"/>
+              </a:rPr>
+              <a:t>, se </a:t>
+            </a:r>
+            <a:r>
+              <a:rPr lang="en-US" sz="1150" dirty="0" err="1">
+                <a:solidFill>
+                  <a:srgbClr val="CADCFC"/>
+                </a:solidFill>
+                <a:latin typeface="Calibri" pitchFamily="34" charset="0"/>
+                <a:ea typeface="Calibri" pitchFamily="34" charset="-122"/>
+                <a:cs typeface="Calibri" pitchFamily="34" charset="-120"/>
+              </a:rPr>
+              <a:t>puede</a:t>
+            </a:r>
+            <a:r>
+              <a:rPr lang="en-US" sz="1150" dirty="0">
+                <a:solidFill>
+                  <a:srgbClr val="CADCFC"/>
+                </a:solidFill>
+                <a:latin typeface="Calibri" pitchFamily="34" charset="0"/>
+                <a:ea typeface="Calibri" pitchFamily="34" charset="-122"/>
+                <a:cs typeface="Calibri" pitchFamily="34" charset="-120"/>
+              </a:rPr>
+              <a:t> inferior que </a:t>
+            </a:r>
+            <a:r>
+              <a:rPr lang="en-US" sz="1150" dirty="0" err="1">
+                <a:solidFill>
+                  <a:srgbClr val="CADCFC"/>
+                </a:solidFill>
+                <a:latin typeface="Calibri" pitchFamily="34" charset="0"/>
+                <a:ea typeface="Calibri" pitchFamily="34" charset="-122"/>
+                <a:cs typeface="Calibri" pitchFamily="34" charset="-120"/>
+              </a:rPr>
+              <a:t>los</a:t>
+            </a:r>
+            <a:r>
+              <a:rPr lang="en-US" sz="1150" dirty="0">
+                <a:solidFill>
+                  <a:srgbClr val="CADCFC"/>
+                </a:solidFill>
+                <a:latin typeface="Calibri" pitchFamily="34" charset="0"/>
+                <a:ea typeface="Calibri" pitchFamily="34" charset="-122"/>
+                <a:cs typeface="Calibri" pitchFamily="34" charset="-120"/>
+              </a:rPr>
+              <a:t> </a:t>
+            </a:r>
+            <a:r>
+              <a:rPr lang="en-US" sz="1150" dirty="0" err="1">
+                <a:solidFill>
+                  <a:srgbClr val="CADCFC"/>
+                </a:solidFill>
+                <a:latin typeface="Calibri" pitchFamily="34" charset="0"/>
+                <a:ea typeface="Calibri" pitchFamily="34" charset="-122"/>
+                <a:cs typeface="Calibri" pitchFamily="34" charset="-120"/>
+              </a:rPr>
+              <a:t>jóvenes</a:t>
+            </a:r>
+            <a:r>
+              <a:rPr lang="en-US" sz="1150" dirty="0">
+                <a:solidFill>
+                  <a:srgbClr val="CADCFC"/>
+                </a:solidFill>
+                <a:latin typeface="Calibri" pitchFamily="34" charset="0"/>
+                <a:ea typeface="Calibri" pitchFamily="34" charset="-122"/>
+                <a:cs typeface="Calibri" pitchFamily="34" charset="-120"/>
+              </a:rPr>
+              <a:t> concentran mayor </a:t>
+            </a:r>
+            <a:r>
+              <a:rPr lang="en-US" sz="1150" dirty="0" err="1">
+                <a:solidFill>
+                  <a:srgbClr val="CADCFC"/>
+                </a:solidFill>
+                <a:latin typeface="Calibri" pitchFamily="34" charset="0"/>
+                <a:ea typeface="Calibri" pitchFamily="34" charset="-122"/>
+                <a:cs typeface="Calibri" pitchFamily="34" charset="-120"/>
+              </a:rPr>
+              <a:t>riesgo</a:t>
+            </a:r>
+            <a:r>
+              <a:rPr lang="en-US" sz="1150" dirty="0">
+                <a:solidFill>
+                  <a:srgbClr val="CADCFC"/>
+                </a:solidFill>
+                <a:latin typeface="Calibri" pitchFamily="34" charset="0"/>
+                <a:ea typeface="Calibri" pitchFamily="34" charset="-122"/>
+                <a:cs typeface="Calibri" pitchFamily="34" charset="-120"/>
+              </a:rPr>
+              <a:t>.</a:t>
             </a:r>
             <a:endParaRPr lang="en-US" sz="1150" dirty="0"/>
           </a:p>

</xml_diff>